<commit_message>
docs: refresh overview deck
Readable Arial typography (renders the same on Windows), larger sizes and
higher-contrast text, fixed duplicated diagram titles, and clearer wording on
the strategy-abstraction and run/test slides.

Co-Authored-By: Claude Opus 4.8 (1M context) <noreply@anthropic.com>
</commit_message>
<xml_diff>
--- a/docs/overview.pptx
+++ b/docs/overview.pptx
@@ -3193,7 +3193,7 @@
         <p:spPr>
           <a:xfrm>
             <a:off x="777240" y="2377440"/>
-            <a:ext cx="10607040" cy="2194560"/>
+            <a:ext cx="10789920" cy="2194560"/>
           </a:xfrm>
           <a:prstGeom prst="rect">
             <a:avLst/>
@@ -3212,11 +3212,11 @@
               </a:spcAft>
             </a:pPr>
             <a:r>
-              <a:rPr sz="5600" b="1">
+              <a:rPr sz="5800" b="1">
                 <a:solidFill>
                   <a:srgbClr val="FFFFFF"/>
                 </a:solidFill>
-                <a:latin typeface="Helvetica Neue"/>
+                <a:latin typeface="Arial"/>
               </a:rPr>
               <a:t>MT5_Trader</a:t>
             </a:r>
@@ -3228,11 +3228,11 @@
               </a:spcAft>
             </a:pPr>
             <a:r>
-              <a:rPr sz="2200" b="0">
+              <a:rPr sz="2400" b="0">
                 <a:solidFill>
                   <a:srgbClr val="CFE0F2"/>
                 </a:solidFill>
-                <a:latin typeface="Helvetica Neue"/>
+                <a:latin typeface="Arial"/>
               </a:rPr>
               <a:t>Quant research + live trading pipeline</a:t>
             </a:r>
@@ -3244,11 +3244,11 @@
               </a:spcAft>
             </a:pPr>
             <a:r>
-              <a:rPr sz="1800" b="0">
+              <a:rPr sz="1900" b="0">
                 <a:solidFill>
                   <a:srgbClr val="9BB6D4"/>
                 </a:solidFill>
-                <a:latin typeface="Helvetica Neue"/>
+                <a:latin typeface="Arial"/>
               </a:rPr>
               <a:t>architecture &amp; code overview</a:t>
             </a:r>
@@ -3264,7 +3264,7 @@
         <p:spPr>
           <a:xfrm>
             <a:off x="822960" y="5074920"/>
-            <a:ext cx="1033272" cy="457200"/>
+            <a:ext cx="1188719" cy="475488"/>
           </a:xfrm>
           <a:prstGeom prst="roundRect">
             <a:avLst/>
@@ -3274,7 +3274,7 @@
           </a:solidFill>
           <a:ln w="15240">
             <a:solidFill>
-              <a:srgbClr val="2F6DB0"/>
+              <a:srgbClr val="3F7CC0"/>
             </a:solidFill>
           </a:ln>
           <a:effectLst/>
@@ -3310,7 +3310,7 @@
         <p:spPr>
           <a:xfrm>
             <a:off x="822960" y="5074920"/>
-            <a:ext cx="1033272" cy="457200"/>
+            <a:ext cx="1188719" cy="475488"/>
           </a:xfrm>
           <a:prstGeom prst="rect">
             <a:avLst/>
@@ -3329,11 +3329,11 @@
               </a:spcAft>
             </a:pPr>
             <a:r>
-              <a:rPr sz="1200" b="0">
-                <a:solidFill>
-                  <a:srgbClr val="CFE0F2"/>
-                </a:solidFill>
-                <a:latin typeface="Helvetica Neue"/>
+              <a:rPr sz="1350" b="0">
+                <a:solidFill>
+                  <a:srgbClr val="DCEAF7"/>
+                </a:solidFill>
+                <a:latin typeface="Arial"/>
               </a:rPr>
               <a:t>Python</a:t>
             </a:r>
@@ -3348,8 +3348,8 @@
         </p:nvSpPr>
         <p:spPr>
           <a:xfrm>
-            <a:off x="2039112" y="5074920"/>
-            <a:ext cx="1033272" cy="457200"/>
+            <a:off x="2212848" y="5074920"/>
+            <a:ext cx="1188719" cy="475488"/>
           </a:xfrm>
           <a:prstGeom prst="roundRect">
             <a:avLst/>
@@ -3359,7 +3359,7 @@
           </a:solidFill>
           <a:ln w="15240">
             <a:solidFill>
-              <a:srgbClr val="2F6DB0"/>
+              <a:srgbClr val="3F7CC0"/>
             </a:solidFill>
           </a:ln>
           <a:effectLst/>
@@ -3394,8 +3394,8 @@
         </p:nvSpPr>
         <p:spPr>
           <a:xfrm>
-            <a:off x="2039112" y="5074920"/>
-            <a:ext cx="1033272" cy="457200"/>
+            <a:off x="2212848" y="5074920"/>
+            <a:ext cx="1188719" cy="475488"/>
           </a:xfrm>
           <a:prstGeom prst="rect">
             <a:avLst/>
@@ -3414,11 +3414,11 @@
               </a:spcAft>
             </a:pPr>
             <a:r>
-              <a:rPr sz="1200" b="0">
-                <a:solidFill>
-                  <a:srgbClr val="CFE0F2"/>
-                </a:solidFill>
-                <a:latin typeface="Helvetica Neue"/>
+              <a:rPr sz="1350" b="0">
+                <a:solidFill>
+                  <a:srgbClr val="DCEAF7"/>
+                </a:solidFill>
+                <a:latin typeface="Arial"/>
               </a:rPr>
               <a:t>polars</a:t>
             </a:r>
@@ -3433,8 +3433,8 @@
         </p:nvSpPr>
         <p:spPr>
           <a:xfrm>
-            <a:off x="3255264" y="5074920"/>
-            <a:ext cx="1156716" cy="457200"/>
+            <a:off x="3602735" y="5074920"/>
+            <a:ext cx="1325880" cy="475488"/>
           </a:xfrm>
           <a:prstGeom prst="roundRect">
             <a:avLst/>
@@ -3444,7 +3444,7 @@
           </a:solidFill>
           <a:ln w="15240">
             <a:solidFill>
-              <a:srgbClr val="2F6DB0"/>
+              <a:srgbClr val="3F7CC0"/>
             </a:solidFill>
           </a:ln>
           <a:effectLst/>
@@ -3479,8 +3479,8 @@
         </p:nvSpPr>
         <p:spPr>
           <a:xfrm>
-            <a:off x="3255264" y="5074920"/>
-            <a:ext cx="1156716" cy="457200"/>
+            <a:off x="3602735" y="5074920"/>
+            <a:ext cx="1325880" cy="475488"/>
           </a:xfrm>
           <a:prstGeom prst="rect">
             <a:avLst/>
@@ -3499,11 +3499,11 @@
               </a:spcAft>
             </a:pPr>
             <a:r>
-              <a:rPr sz="1200" b="0">
-                <a:solidFill>
-                  <a:srgbClr val="CFE0F2"/>
-                </a:solidFill>
-                <a:latin typeface="Helvetica Neue"/>
+              <a:rPr sz="1350" b="0">
+                <a:solidFill>
+                  <a:srgbClr val="DCEAF7"/>
+                </a:solidFill>
+                <a:latin typeface="Arial"/>
               </a:rPr>
               <a:t>pyarrow</a:t>
             </a:r>
@@ -3518,8 +3518,8 @@
         </p:nvSpPr>
         <p:spPr>
           <a:xfrm>
-            <a:off x="4594860" y="5074920"/>
-            <a:ext cx="2144268" cy="457200"/>
+            <a:off x="5129783" y="5074920"/>
+            <a:ext cx="2423160" cy="475488"/>
           </a:xfrm>
           <a:prstGeom prst="roundRect">
             <a:avLst/>
@@ -3529,7 +3529,7 @@
           </a:solidFill>
           <a:ln w="15240">
             <a:solidFill>
-              <a:srgbClr val="2F6DB0"/>
+              <a:srgbClr val="3F7CC0"/>
             </a:solidFill>
           </a:ln>
           <a:effectLst/>
@@ -3564,8 +3564,8 @@
         </p:nvSpPr>
         <p:spPr>
           <a:xfrm>
-            <a:off x="4594860" y="5074920"/>
-            <a:ext cx="2144268" cy="457200"/>
+            <a:off x="5129783" y="5074920"/>
+            <a:ext cx="2423160" cy="475488"/>
           </a:xfrm>
           <a:prstGeom prst="rect">
             <a:avLst/>
@@ -3584,11 +3584,11 @@
               </a:spcAft>
             </a:pPr>
             <a:r>
-              <a:rPr sz="1200" b="0">
-                <a:solidFill>
-                  <a:srgbClr val="CFE0F2"/>
-                </a:solidFill>
-                <a:latin typeface="Helvetica Neue"/>
+              <a:rPr sz="1350" b="0">
+                <a:solidFill>
+                  <a:srgbClr val="DCEAF7"/>
+                </a:solidFill>
+                <a:latin typeface="Arial"/>
               </a:rPr>
               <a:t>backtest engine</a:t>
             </a:r>
@@ -3603,8 +3603,8 @@
         </p:nvSpPr>
         <p:spPr>
           <a:xfrm>
-            <a:off x="6922008" y="5074920"/>
-            <a:ext cx="1650492" cy="457200"/>
+            <a:off x="7754112" y="5074920"/>
+            <a:ext cx="1874519" cy="475488"/>
           </a:xfrm>
           <a:prstGeom prst="roundRect">
             <a:avLst/>
@@ -3614,7 +3614,7 @@
           </a:solidFill>
           <a:ln w="15240">
             <a:solidFill>
-              <a:srgbClr val="2F6DB0"/>
+              <a:srgbClr val="3F7CC0"/>
             </a:solidFill>
           </a:ln>
           <a:effectLst/>
@@ -3649,8 +3649,8 @@
         </p:nvSpPr>
         <p:spPr>
           <a:xfrm>
-            <a:off x="6922008" y="5074920"/>
-            <a:ext cx="1650492" cy="457200"/>
+            <a:off x="7754112" y="5074920"/>
+            <a:ext cx="1874519" cy="475488"/>
           </a:xfrm>
           <a:prstGeom prst="rect">
             <a:avLst/>
@@ -3669,11 +3669,11 @@
               </a:spcAft>
             </a:pPr>
             <a:r>
-              <a:rPr sz="1200" b="0">
-                <a:solidFill>
-                  <a:srgbClr val="CFE0F2"/>
-                </a:solidFill>
-                <a:latin typeface="Helvetica Neue"/>
+              <a:rPr sz="1350" b="0">
+                <a:solidFill>
+                  <a:srgbClr val="DCEAF7"/>
+                </a:solidFill>
+                <a:latin typeface="Arial"/>
               </a:rPr>
               <a:t>MetaTrader5</a:t>
             </a:r>
@@ -3688,8 +3688,8 @@
         </p:nvSpPr>
         <p:spPr>
           <a:xfrm>
-            <a:off x="8755380" y="5074920"/>
-            <a:ext cx="1403604" cy="457200"/>
+            <a:off x="9829800" y="5074920"/>
+            <a:ext cx="1600200" cy="475488"/>
           </a:xfrm>
           <a:prstGeom prst="roundRect">
             <a:avLst/>
@@ -3699,7 +3699,7 @@
           </a:solidFill>
           <a:ln w="15240">
             <a:solidFill>
-              <a:srgbClr val="2F6DB0"/>
+              <a:srgbClr val="3F7CC0"/>
             </a:solidFill>
           </a:ln>
           <a:effectLst/>
@@ -3734,8 +3734,8 @@
         </p:nvSpPr>
         <p:spPr>
           <a:xfrm>
-            <a:off x="8755380" y="5074920"/>
-            <a:ext cx="1403604" cy="457200"/>
+            <a:off x="9829800" y="5074920"/>
+            <a:ext cx="1600200" cy="475488"/>
           </a:xfrm>
           <a:prstGeom prst="rect">
             <a:avLst/>
@@ -3754,11 +3754,11 @@
               </a:spcAft>
             </a:pPr>
             <a:r>
-              <a:rPr sz="1200" b="0">
-                <a:solidFill>
-                  <a:srgbClr val="CFE0F2"/>
-                </a:solidFill>
-                <a:latin typeface="Helvetica Neue"/>
+              <a:rPr sz="1350" b="0">
+                <a:solidFill>
+                  <a:srgbClr val="DCEAF7"/>
+                </a:solidFill>
+                <a:latin typeface="Arial"/>
               </a:rPr>
               <a:t>Streamlit</a:t>
             </a:r>
@@ -3879,7 +3879,7 @@
         </p:nvSpPr>
         <p:spPr>
           <a:xfrm>
-            <a:off x="502920" y="6419088"/>
+            <a:off x="502920" y="6400800"/>
             <a:ext cx="5486400" cy="365760"/>
           </a:xfrm>
           <a:prstGeom prst="rect">
@@ -3899,11 +3899,11 @@
               </a:spcAft>
             </a:pPr>
             <a:r>
-              <a:rPr sz="900" b="0">
-                <a:solidFill>
-                  <a:srgbClr val="64748B"/>
-                </a:solidFill>
-                <a:latin typeface="Helvetica Neue"/>
+              <a:rPr sz="1100" b="0">
+                <a:solidFill>
+                  <a:srgbClr val="5B6B7B"/>
+                </a:solidFill>
+                <a:latin typeface="Arial"/>
               </a:rPr>
               <a:t>MT5_Trader</a:t>
             </a:r>
@@ -3918,7 +3918,7 @@
         </p:nvSpPr>
         <p:spPr>
           <a:xfrm>
-            <a:off x="9875520" y="6419088"/>
+            <a:off x="9875520" y="6400800"/>
             <a:ext cx="1828800" cy="365760"/>
           </a:xfrm>
           <a:prstGeom prst="rect">
@@ -3938,11 +3938,11 @@
               </a:spcAft>
             </a:pPr>
             <a:r>
-              <a:rPr sz="900" b="0">
-                <a:solidFill>
-                  <a:srgbClr val="64748B"/>
-                </a:solidFill>
-                <a:latin typeface="Helvetica Neue"/>
+              <a:rPr sz="1100" b="0">
+                <a:solidFill>
+                  <a:srgbClr val="5B6B7B"/>
+                </a:solidFill>
+                <a:latin typeface="Arial"/>
               </a:rPr>
               <a:t>2 / 9</a:t>
             </a:r>
@@ -3957,8 +3957,8 @@
         </p:nvSpPr>
         <p:spPr>
           <a:xfrm>
-            <a:off x="502920" y="411480"/>
-            <a:ext cx="11155680" cy="1005840"/>
+            <a:off x="502920" y="384048"/>
+            <a:ext cx="11155680" cy="1051560"/>
           </a:xfrm>
           <a:prstGeom prst="rect">
             <a:avLst/>
@@ -3977,11 +3977,11 @@
               </a:spcAft>
             </a:pPr>
             <a:r>
-              <a:rPr sz="3000" b="1">
+              <a:rPr sz="3300" b="1">
                 <a:solidFill>
                   <a:srgbClr val="0F2A43"/>
                 </a:solidFill>
-                <a:latin typeface="Helvetica Neue"/>
+                <a:latin typeface="Arial"/>
               </a:rPr>
               <a:t>Tech stack</a:t>
             </a:r>
@@ -3996,8 +3996,8 @@
         </p:nvSpPr>
         <p:spPr>
           <a:xfrm>
-            <a:off x="502920" y="1508760"/>
-            <a:ext cx="2697480" cy="2057400"/>
+            <a:off x="502920" y="1554480"/>
+            <a:ext cx="2697480" cy="2103120"/>
           </a:xfrm>
           <a:prstGeom prst="roundRect">
             <a:avLst/>
@@ -4007,7 +4007,7 @@
           </a:solidFill>
           <a:ln w="15240">
             <a:solidFill>
-              <a:srgbClr val="DBE4EE"/>
+              <a:srgbClr val="CFDAE6"/>
             </a:solidFill>
           </a:ln>
           <a:effectLst/>
@@ -4042,14 +4042,14 @@
         </p:nvSpPr>
         <p:spPr>
           <a:xfrm>
-            <a:off x="502920" y="1508760"/>
-            <a:ext cx="2697480" cy="420624"/>
+            <a:off x="502920" y="1554480"/>
+            <a:ext cx="2697480" cy="457200"/>
           </a:xfrm>
           <a:prstGeom prst="roundRect">
             <a:avLst/>
           </a:prstGeom>
           <a:solidFill>
-            <a:srgbClr val="64748B"/>
+            <a:srgbClr val="5B6B7B"/>
           </a:solidFill>
           <a:ln>
             <a:noFill/>
@@ -4086,8 +4086,8 @@
         </p:nvSpPr>
         <p:spPr>
           <a:xfrm>
-            <a:off x="612648" y="1527048"/>
-            <a:ext cx="2514600" cy="384048"/>
+            <a:off x="630936" y="1572768"/>
+            <a:ext cx="2478024" cy="420624"/>
           </a:xfrm>
           <a:prstGeom prst="rect">
             <a:avLst/>
@@ -4106,11 +4106,11 @@
               </a:spcAft>
             </a:pPr>
             <a:r>
-              <a:rPr sz="1250" b="1">
+              <a:rPr sz="1400" b="1">
                 <a:solidFill>
                   <a:srgbClr val="FFFFFF"/>
                 </a:solidFill>
-                <a:latin typeface="Helvetica Neue"/>
+                <a:latin typeface="Arial"/>
               </a:rPr>
               <a:t>Language &amp; build</a:t>
             </a:r>
@@ -4125,8 +4125,8 @@
         </p:nvSpPr>
         <p:spPr>
           <a:xfrm>
-            <a:off x="667512" y="2039112"/>
-            <a:ext cx="2423160" cy="1508760"/>
+            <a:off x="685800" y="2121408"/>
+            <a:ext cx="2386584" cy="1499615"/>
           </a:xfrm>
           <a:prstGeom prst="rect">
             <a:avLst/>
@@ -4141,49 +4141,49 @@
           <a:p>
             <a:pPr algn="l">
               <a:spcAft>
-                <a:spcPts val="300"/>
-              </a:spcAft>
-            </a:pPr>
-            <a:r>
-              <a:rPr sz="1150" b="0">
-                <a:solidFill>
-                  <a:srgbClr val="1B2733"/>
-                </a:solidFill>
-                <a:latin typeface="Helvetica Neue"/>
-              </a:rPr>
-              <a:t>• Python ≥3.11</a:t>
+                <a:spcPts val="400"/>
+              </a:spcAft>
+            </a:pPr>
+            <a:r>
+              <a:rPr sz="1350" b="0">
+                <a:solidFill>
+                  <a:srgbClr val="16222E"/>
+                </a:solidFill>
+                <a:latin typeface="Arial"/>
+              </a:rPr>
+              <a:t>•  Python ≥3.11</a:t>
             </a:r>
           </a:p>
           <a:p>
             <a:pPr algn="l">
               <a:spcAft>
-                <a:spcPts val="300"/>
-              </a:spcAft>
-            </a:pPr>
-            <a:r>
-              <a:rPr sz="1150" b="0">
-                <a:solidFill>
-                  <a:srgbClr val="1B2733"/>
-                </a:solidFill>
-                <a:latin typeface="Helvetica Neue"/>
-              </a:rPr>
-              <a:t>• hatchling</a:t>
+                <a:spcPts val="400"/>
+              </a:spcAft>
+            </a:pPr>
+            <a:r>
+              <a:rPr sz="1350" b="0">
+                <a:solidFill>
+                  <a:srgbClr val="16222E"/>
+                </a:solidFill>
+                <a:latin typeface="Arial"/>
+              </a:rPr>
+              <a:t>•  hatchling</a:t>
             </a:r>
           </a:p>
           <a:p>
             <a:pPr algn="l">
               <a:spcAft>
-                <a:spcPts val="300"/>
-              </a:spcAft>
-            </a:pPr>
-            <a:r>
-              <a:rPr sz="1150" b="0">
-                <a:solidFill>
-                  <a:srgbClr val="1B2733"/>
-                </a:solidFill>
-                <a:latin typeface="Helvetica Neue"/>
-              </a:rPr>
-              <a:t>• uv</a:t>
+                <a:spcPts val="400"/>
+              </a:spcAft>
+            </a:pPr>
+            <a:r>
+              <a:rPr sz="1350" b="0">
+                <a:solidFill>
+                  <a:srgbClr val="16222E"/>
+                </a:solidFill>
+                <a:latin typeface="Arial"/>
+              </a:rPr>
+              <a:t>•  uv</a:t>
             </a:r>
           </a:p>
         </p:txBody>
@@ -4196,8 +4196,8 @@
         </p:nvSpPr>
         <p:spPr>
           <a:xfrm>
-            <a:off x="3364992" y="1508760"/>
-            <a:ext cx="2697480" cy="2057400"/>
+            <a:off x="3364992" y="1554480"/>
+            <a:ext cx="2697480" cy="2103120"/>
           </a:xfrm>
           <a:prstGeom prst="roundRect">
             <a:avLst/>
@@ -4207,7 +4207,7 @@
           </a:solidFill>
           <a:ln w="15240">
             <a:solidFill>
-              <a:srgbClr val="DBE4EE"/>
+              <a:srgbClr val="CFDAE6"/>
             </a:solidFill>
           </a:ln>
           <a:effectLst/>
@@ -4242,8 +4242,8 @@
         </p:nvSpPr>
         <p:spPr>
           <a:xfrm>
-            <a:off x="3364992" y="1508760"/>
-            <a:ext cx="2697480" cy="420624"/>
+            <a:off x="3364992" y="1554480"/>
+            <a:ext cx="2697480" cy="457200"/>
           </a:xfrm>
           <a:prstGeom prst="roundRect">
             <a:avLst/>
@@ -4286,8 +4286,8 @@
         </p:nvSpPr>
         <p:spPr>
           <a:xfrm>
-            <a:off x="3474720" y="1527048"/>
-            <a:ext cx="2514600" cy="384048"/>
+            <a:off x="3493008" y="1572768"/>
+            <a:ext cx="2478024" cy="420624"/>
           </a:xfrm>
           <a:prstGeom prst="rect">
             <a:avLst/>
@@ -4306,11 +4306,11 @@
               </a:spcAft>
             </a:pPr>
             <a:r>
-              <a:rPr sz="1250" b="1">
+              <a:rPr sz="1400" b="1">
                 <a:solidFill>
                   <a:srgbClr val="FFFFFF"/>
                 </a:solidFill>
-                <a:latin typeface="Helvetica Neue"/>
+                <a:latin typeface="Arial"/>
               </a:rPr>
               <a:t>Data &amp; compute</a:t>
             </a:r>
@@ -4325,8 +4325,8 @@
         </p:nvSpPr>
         <p:spPr>
           <a:xfrm>
-            <a:off x="3529584" y="2039112"/>
-            <a:ext cx="2423160" cy="1508760"/>
+            <a:off x="3547872" y="2121408"/>
+            <a:ext cx="2386584" cy="1499615"/>
           </a:xfrm>
           <a:prstGeom prst="rect">
             <a:avLst/>
@@ -4341,49 +4341,49 @@
           <a:p>
             <a:pPr algn="l">
               <a:spcAft>
-                <a:spcPts val="300"/>
-              </a:spcAft>
-            </a:pPr>
-            <a:r>
-              <a:rPr sz="1150" b="0">
-                <a:solidFill>
-                  <a:srgbClr val="1B2733"/>
-                </a:solidFill>
-                <a:latin typeface="Helvetica Neue"/>
-              </a:rPr>
-              <a:t>• polars</a:t>
+                <a:spcPts val="400"/>
+              </a:spcAft>
+            </a:pPr>
+            <a:r>
+              <a:rPr sz="1350" b="0">
+                <a:solidFill>
+                  <a:srgbClr val="16222E"/>
+                </a:solidFill>
+                <a:latin typeface="Arial"/>
+              </a:rPr>
+              <a:t>•  polars</a:t>
             </a:r>
           </a:p>
           <a:p>
             <a:pPr algn="l">
               <a:spcAft>
-                <a:spcPts val="300"/>
-              </a:spcAft>
-            </a:pPr>
-            <a:r>
-              <a:rPr sz="1150" b="0">
-                <a:solidFill>
-                  <a:srgbClr val="1B2733"/>
-                </a:solidFill>
-                <a:latin typeface="Helvetica Neue"/>
-              </a:rPr>
-              <a:t>• pyarrow</a:t>
+                <a:spcPts val="400"/>
+              </a:spcAft>
+            </a:pPr>
+            <a:r>
+              <a:rPr sz="1350" b="0">
+                <a:solidFill>
+                  <a:srgbClr val="16222E"/>
+                </a:solidFill>
+                <a:latin typeface="Arial"/>
+              </a:rPr>
+              <a:t>•  pyarrow</a:t>
             </a:r>
           </a:p>
           <a:p>
             <a:pPr algn="l">
               <a:spcAft>
-                <a:spcPts val="300"/>
-              </a:spcAft>
-            </a:pPr>
-            <a:r>
-              <a:rPr sz="1150" b="0">
-                <a:solidFill>
-                  <a:srgbClr val="1B2733"/>
-                </a:solidFill>
-                <a:latin typeface="Helvetica Neue"/>
-              </a:rPr>
-              <a:t>• numpy · scipy</a:t>
+                <a:spcPts val="400"/>
+              </a:spcAft>
+            </a:pPr>
+            <a:r>
+              <a:rPr sz="1350" b="0">
+                <a:solidFill>
+                  <a:srgbClr val="16222E"/>
+                </a:solidFill>
+                <a:latin typeface="Arial"/>
+              </a:rPr>
+              <a:t>•  numpy · scipy</a:t>
             </a:r>
           </a:p>
         </p:txBody>
@@ -4396,8 +4396,8 @@
         </p:nvSpPr>
         <p:spPr>
           <a:xfrm>
-            <a:off x="6227064" y="1508760"/>
-            <a:ext cx="2697480" cy="2057400"/>
+            <a:off x="6227064" y="1554480"/>
+            <a:ext cx="2697480" cy="2103120"/>
           </a:xfrm>
           <a:prstGeom prst="roundRect">
             <a:avLst/>
@@ -4407,7 +4407,7 @@
           </a:solidFill>
           <a:ln w="15240">
             <a:solidFill>
-              <a:srgbClr val="DBE4EE"/>
+              <a:srgbClr val="CFDAE6"/>
             </a:solidFill>
           </a:ln>
           <a:effectLst/>
@@ -4442,8 +4442,8 @@
         </p:nvSpPr>
         <p:spPr>
           <a:xfrm>
-            <a:off x="6227064" y="1508760"/>
-            <a:ext cx="2697480" cy="420624"/>
+            <a:off x="6227064" y="1554480"/>
+            <a:ext cx="2697480" cy="457200"/>
           </a:xfrm>
           <a:prstGeom prst="roundRect">
             <a:avLst/>
@@ -4486,8 +4486,8 @@
         </p:nvSpPr>
         <p:spPr>
           <a:xfrm>
-            <a:off x="6336792" y="1527048"/>
-            <a:ext cx="2514600" cy="384048"/>
+            <a:off x="6355080" y="1572768"/>
+            <a:ext cx="2478024" cy="420624"/>
           </a:xfrm>
           <a:prstGeom prst="rect">
             <a:avLst/>
@@ -4506,11 +4506,11 @@
               </a:spcAft>
             </a:pPr>
             <a:r>
-              <a:rPr sz="1250" b="1">
+              <a:rPr sz="1400" b="1">
                 <a:solidFill>
                   <a:srgbClr val="FFFFFF"/>
                 </a:solidFill>
-                <a:latin typeface="Helvetica Neue"/>
+                <a:latin typeface="Arial"/>
               </a:rPr>
               <a:t>Backtest &amp; research</a:t>
             </a:r>
@@ -4525,8 +4525,8 @@
         </p:nvSpPr>
         <p:spPr>
           <a:xfrm>
-            <a:off x="6391656" y="2039112"/>
-            <a:ext cx="2423160" cy="1508760"/>
+            <a:off x="6409944" y="2121408"/>
+            <a:ext cx="2386584" cy="1499615"/>
           </a:xfrm>
           <a:prstGeom prst="rect">
             <a:avLst/>
@@ -4541,49 +4541,49 @@
           <a:p>
             <a:pPr algn="l">
               <a:spcAft>
-                <a:spcPts val="300"/>
-              </a:spcAft>
-            </a:pPr>
-            <a:r>
-              <a:rPr sz="1150" b="0">
-                <a:solidFill>
-                  <a:srgbClr val="1B2733"/>
-                </a:solidFill>
-                <a:latin typeface="Helvetica Neue"/>
-              </a:rPr>
-              <a:t>• no-lookahead engine</a:t>
+                <a:spcPts val="400"/>
+              </a:spcAft>
+            </a:pPr>
+            <a:r>
+              <a:rPr sz="1350" b="0">
+                <a:solidFill>
+                  <a:srgbClr val="16222E"/>
+                </a:solidFill>
+                <a:latin typeface="Arial"/>
+              </a:rPr>
+              <a:t>•  no-lookahead engine</a:t>
             </a:r>
           </a:p>
           <a:p>
             <a:pPr algn="l">
               <a:spcAft>
-                <a:spcPts val="300"/>
-              </a:spcAft>
-            </a:pPr>
-            <a:r>
-              <a:rPr sz="1150" b="0">
-                <a:solidFill>
-                  <a:srgbClr val="1B2733"/>
-                </a:solidFill>
-                <a:latin typeface="Helvetica Neue"/>
-              </a:rPr>
-              <a:t>• matplotlib</a:t>
+                <a:spcPts val="400"/>
+              </a:spcAft>
+            </a:pPr>
+            <a:r>
+              <a:rPr sz="1350" b="0">
+                <a:solidFill>
+                  <a:srgbClr val="16222E"/>
+                </a:solidFill>
+                <a:latin typeface="Arial"/>
+              </a:rPr>
+              <a:t>•  matplotlib</a:t>
             </a:r>
           </a:p>
           <a:p>
             <a:pPr algn="l">
               <a:spcAft>
-                <a:spcPts val="300"/>
-              </a:spcAft>
-            </a:pPr>
-            <a:r>
-              <a:rPr sz="1150" b="0">
-                <a:solidFill>
-                  <a:srgbClr val="1B2733"/>
-                </a:solidFill>
-                <a:latin typeface="Helvetica Neue"/>
-              </a:rPr>
-              <a:t>• JupyterLab · pytest</a:t>
+                <a:spcPts val="400"/>
+              </a:spcAft>
+            </a:pPr>
+            <a:r>
+              <a:rPr sz="1350" b="0">
+                <a:solidFill>
+                  <a:srgbClr val="16222E"/>
+                </a:solidFill>
+                <a:latin typeface="Arial"/>
+              </a:rPr>
+              <a:t>•  JupyterLab · pytest</a:t>
             </a:r>
           </a:p>
         </p:txBody>
@@ -4596,8 +4596,8 @@
         </p:nvSpPr>
         <p:spPr>
           <a:xfrm>
-            <a:off x="9089136" y="1508760"/>
-            <a:ext cx="2697480" cy="2057400"/>
+            <a:off x="9089136" y="1554480"/>
+            <a:ext cx="2697480" cy="2103120"/>
           </a:xfrm>
           <a:prstGeom prst="roundRect">
             <a:avLst/>
@@ -4607,7 +4607,7 @@
           </a:solidFill>
           <a:ln w="15240">
             <a:solidFill>
-              <a:srgbClr val="DBE4EE"/>
+              <a:srgbClr val="CFDAE6"/>
             </a:solidFill>
           </a:ln>
           <a:effectLst/>
@@ -4642,14 +4642,14 @@
         </p:nvSpPr>
         <p:spPr>
           <a:xfrm>
-            <a:off x="9089136" y="1508760"/>
-            <a:ext cx="2697480" cy="420624"/>
+            <a:off x="9089136" y="1554480"/>
+            <a:ext cx="2697480" cy="457200"/>
           </a:xfrm>
           <a:prstGeom prst="roundRect">
             <a:avLst/>
           </a:prstGeom>
           <a:solidFill>
-            <a:srgbClr val="E0962F"/>
+            <a:srgbClr val="D98B22"/>
           </a:solidFill>
           <a:ln>
             <a:noFill/>
@@ -4686,8 +4686,8 @@
         </p:nvSpPr>
         <p:spPr>
           <a:xfrm>
-            <a:off x="9198864" y="1527048"/>
-            <a:ext cx="2514600" cy="384048"/>
+            <a:off x="9217152" y="1572768"/>
+            <a:ext cx="2478024" cy="420624"/>
           </a:xfrm>
           <a:prstGeom prst="rect">
             <a:avLst/>
@@ -4706,11 +4706,11 @@
               </a:spcAft>
             </a:pPr>
             <a:r>
-              <a:rPr sz="1250" b="1">
+              <a:rPr sz="1400" b="1">
                 <a:solidFill>
                   <a:srgbClr val="FFFFFF"/>
                 </a:solidFill>
-                <a:latin typeface="Helvetica Neue"/>
+                <a:latin typeface="Arial"/>
               </a:rPr>
               <a:t>Live execution</a:t>
             </a:r>
@@ -4725,8 +4725,8 @@
         </p:nvSpPr>
         <p:spPr>
           <a:xfrm>
-            <a:off x="9253728" y="2039112"/>
-            <a:ext cx="2423160" cy="1508760"/>
+            <a:off x="9272016" y="2121408"/>
+            <a:ext cx="2386584" cy="1499615"/>
           </a:xfrm>
           <a:prstGeom prst="rect">
             <a:avLst/>
@@ -4741,49 +4741,49 @@
           <a:p>
             <a:pPr algn="l">
               <a:spcAft>
-                <a:spcPts val="300"/>
-              </a:spcAft>
-            </a:pPr>
-            <a:r>
-              <a:rPr sz="1150" b="0">
-                <a:solidFill>
-                  <a:srgbClr val="1B2733"/>
-                </a:solidFill>
-                <a:latin typeface="Helvetica Neue"/>
-              </a:rPr>
-              <a:t>• MetaTrader5</a:t>
+                <a:spcPts val="400"/>
+              </a:spcAft>
+            </a:pPr>
+            <a:r>
+              <a:rPr sz="1350" b="0">
+                <a:solidFill>
+                  <a:srgbClr val="16222E"/>
+                </a:solidFill>
+                <a:latin typeface="Arial"/>
+              </a:rPr>
+              <a:t>•  MetaTrader5</a:t>
             </a:r>
           </a:p>
           <a:p>
             <a:pPr algn="l">
               <a:spcAft>
-                <a:spcPts val="300"/>
-              </a:spcAft>
-            </a:pPr>
-            <a:r>
-              <a:rPr sz="1150" b="0">
-                <a:solidFill>
-                  <a:srgbClr val="1B2733"/>
-                </a:solidFill>
-                <a:latin typeface="Helvetica Neue"/>
-              </a:rPr>
-              <a:t>• runner loop · watchdog</a:t>
+                <a:spcPts val="400"/>
+              </a:spcAft>
+            </a:pPr>
+            <a:r>
+              <a:rPr sz="1350" b="0">
+                <a:solidFill>
+                  <a:srgbClr val="16222E"/>
+                </a:solidFill>
+                <a:latin typeface="Arial"/>
+              </a:rPr>
+              <a:t>•  runner loop · watchdog</a:t>
             </a:r>
           </a:p>
           <a:p>
             <a:pPr algn="l">
               <a:spcAft>
-                <a:spcPts val="300"/>
-              </a:spcAft>
-            </a:pPr>
-            <a:r>
-              <a:rPr sz="1150" b="0">
-                <a:solidFill>
-                  <a:srgbClr val="1B2733"/>
-                </a:solidFill>
-                <a:latin typeface="Helvetica Neue"/>
-              </a:rPr>
-              <a:t>• Telegram alerts</a:t>
+                <a:spcPts val="400"/>
+              </a:spcAft>
+            </a:pPr>
+            <a:r>
+              <a:rPr sz="1350" b="0">
+                <a:solidFill>
+                  <a:srgbClr val="16222E"/>
+                </a:solidFill>
+                <a:latin typeface="Arial"/>
+              </a:rPr>
+              <a:t>•  Telegram alerts</a:t>
             </a:r>
           </a:p>
         </p:txBody>
@@ -4796,8 +4796,8 @@
         </p:nvSpPr>
         <p:spPr>
           <a:xfrm>
-            <a:off x="502920" y="3822191"/>
-            <a:ext cx="2697480" cy="2057400"/>
+            <a:off x="502920" y="3931920"/>
+            <a:ext cx="2697480" cy="2103120"/>
           </a:xfrm>
           <a:prstGeom prst="roundRect">
             <a:avLst/>
@@ -4807,7 +4807,7 @@
           </a:solidFill>
           <a:ln w="15240">
             <a:solidFill>
-              <a:srgbClr val="DBE4EE"/>
+              <a:srgbClr val="CFDAE6"/>
             </a:solidFill>
           </a:ln>
           <a:effectLst/>
@@ -4842,8 +4842,8 @@
         </p:nvSpPr>
         <p:spPr>
           <a:xfrm>
-            <a:off x="502920" y="3822191"/>
-            <a:ext cx="2697480" cy="420624"/>
+            <a:off x="502920" y="3931920"/>
+            <a:ext cx="2697480" cy="457200"/>
           </a:xfrm>
           <a:prstGeom prst="roundRect">
             <a:avLst/>
@@ -4886,8 +4886,8 @@
         </p:nvSpPr>
         <p:spPr>
           <a:xfrm>
-            <a:off x="612648" y="3840479"/>
-            <a:ext cx="2514600" cy="384048"/>
+            <a:off x="630936" y="3950207"/>
+            <a:ext cx="2478024" cy="420624"/>
           </a:xfrm>
           <a:prstGeom prst="rect">
             <a:avLst/>
@@ -4906,11 +4906,11 @@
               </a:spcAft>
             </a:pPr>
             <a:r>
-              <a:rPr sz="1250" b="1">
+              <a:rPr sz="1400" b="1">
                 <a:solidFill>
                   <a:srgbClr val="FFFFFF"/>
                 </a:solidFill>
-                <a:latin typeface="Helvetica Neue"/>
+                <a:latin typeface="Arial"/>
               </a:rPr>
               <a:t>Config &amp; secrets</a:t>
             </a:r>
@@ -4925,8 +4925,8 @@
         </p:nvSpPr>
         <p:spPr>
           <a:xfrm>
-            <a:off x="667512" y="4352544"/>
-            <a:ext cx="2423160" cy="1508760"/>
+            <a:off x="685800" y="4498848"/>
+            <a:ext cx="2386584" cy="1499615"/>
           </a:xfrm>
           <a:prstGeom prst="rect">
             <a:avLst/>
@@ -4941,33 +4941,33 @@
           <a:p>
             <a:pPr algn="l">
               <a:spcAft>
-                <a:spcPts val="300"/>
-              </a:spcAft>
-            </a:pPr>
-            <a:r>
-              <a:rPr sz="1150" b="0">
-                <a:solidFill>
-                  <a:srgbClr val="1B2733"/>
-                </a:solidFill>
-                <a:latin typeface="Helvetica Neue"/>
-              </a:rPr>
-              <a:t>• pyyaml (config/*.yaml)</a:t>
+                <a:spcPts val="400"/>
+              </a:spcAft>
+            </a:pPr>
+            <a:r>
+              <a:rPr sz="1350" b="0">
+                <a:solidFill>
+                  <a:srgbClr val="16222E"/>
+                </a:solidFill>
+                <a:latin typeface="Arial"/>
+              </a:rPr>
+              <a:t>•  pyyaml (config/*.yaml)</a:t>
             </a:r>
           </a:p>
           <a:p>
             <a:pPr algn="l">
               <a:spcAft>
-                <a:spcPts val="300"/>
-              </a:spcAft>
-            </a:pPr>
-            <a:r>
-              <a:rPr sz="1150" b="0">
-                <a:solidFill>
-                  <a:srgbClr val="1B2733"/>
-                </a:solidFill>
-                <a:latin typeface="Helvetica Neue"/>
-              </a:rPr>
-              <a:t>• python-dotenv</a:t>
+                <a:spcPts val="400"/>
+              </a:spcAft>
+            </a:pPr>
+            <a:r>
+              <a:rPr sz="1350" b="0">
+                <a:solidFill>
+                  <a:srgbClr val="16222E"/>
+                </a:solidFill>
+                <a:latin typeface="Arial"/>
+              </a:rPr>
+              <a:t>•  python-dotenv</a:t>
             </a:r>
           </a:p>
         </p:txBody>
@@ -4980,8 +4980,8 @@
         </p:nvSpPr>
         <p:spPr>
           <a:xfrm>
-            <a:off x="3364992" y="3822191"/>
-            <a:ext cx="2697480" cy="2057400"/>
+            <a:off x="3364992" y="3931920"/>
+            <a:ext cx="2697480" cy="2103120"/>
           </a:xfrm>
           <a:prstGeom prst="roundRect">
             <a:avLst/>
@@ -4991,7 +4991,7 @@
           </a:solidFill>
           <a:ln w="15240">
             <a:solidFill>
-              <a:srgbClr val="DBE4EE"/>
+              <a:srgbClr val="CFDAE6"/>
             </a:solidFill>
           </a:ln>
           <a:effectLst/>
@@ -5026,8 +5026,8 @@
         </p:nvSpPr>
         <p:spPr>
           <a:xfrm>
-            <a:off x="3364992" y="3822191"/>
-            <a:ext cx="2697480" cy="420624"/>
+            <a:off x="3364992" y="3931920"/>
+            <a:ext cx="2697480" cy="457200"/>
           </a:xfrm>
           <a:prstGeom prst="roundRect">
             <a:avLst/>
@@ -5070,8 +5070,8 @@
         </p:nvSpPr>
         <p:spPr>
           <a:xfrm>
-            <a:off x="3474720" y="3840479"/>
-            <a:ext cx="2514600" cy="384048"/>
+            <a:off x="3493008" y="3950207"/>
+            <a:ext cx="2478024" cy="420624"/>
           </a:xfrm>
           <a:prstGeom prst="rect">
             <a:avLst/>
@@ -5090,11 +5090,11 @@
               </a:spcAft>
             </a:pPr>
             <a:r>
-              <a:rPr sz="1250" b="1">
+              <a:rPr sz="1400" b="1">
                 <a:solidFill>
                   <a:srgbClr val="FFFFFF"/>
                 </a:solidFill>
-                <a:latin typeface="Helvetica Neue"/>
+                <a:latin typeface="Arial"/>
               </a:rPr>
               <a:t>Dashboard</a:t>
             </a:r>
@@ -5109,8 +5109,8 @@
         </p:nvSpPr>
         <p:spPr>
           <a:xfrm>
-            <a:off x="3529584" y="4352544"/>
-            <a:ext cx="2423160" cy="1508760"/>
+            <a:off x="3547872" y="4498848"/>
+            <a:ext cx="2386584" cy="1499615"/>
           </a:xfrm>
           <a:prstGeom prst="rect">
             <a:avLst/>
@@ -5125,33 +5125,33 @@
           <a:p>
             <a:pPr algn="l">
               <a:spcAft>
-                <a:spcPts val="300"/>
-              </a:spcAft>
-            </a:pPr>
-            <a:r>
-              <a:rPr sz="1150" b="0">
-                <a:solidFill>
-                  <a:srgbClr val="1B2733"/>
-                </a:solidFill>
-                <a:latin typeface="Helvetica Neue"/>
-              </a:rPr>
-              <a:t>• Streamlit</a:t>
+                <a:spcPts val="400"/>
+              </a:spcAft>
+            </a:pPr>
+            <a:r>
+              <a:rPr sz="1350" b="0">
+                <a:solidFill>
+                  <a:srgbClr val="16222E"/>
+                </a:solidFill>
+                <a:latin typeface="Arial"/>
+              </a:rPr>
+              <a:t>•  Streamlit</a:t>
             </a:r>
           </a:p>
           <a:p>
             <a:pPr algn="l">
               <a:spcAft>
-                <a:spcPts val="300"/>
-              </a:spcAft>
-            </a:pPr>
-            <a:r>
-              <a:rPr sz="1150" b="0">
-                <a:solidFill>
-                  <a:srgbClr val="1B2733"/>
-                </a:solidFill>
-                <a:latin typeface="Helvetica Neue"/>
-              </a:rPr>
-              <a:t>• Plotly · pandas</a:t>
+                <a:spcPts val="400"/>
+              </a:spcAft>
+            </a:pPr>
+            <a:r>
+              <a:rPr sz="1350" b="0">
+                <a:solidFill>
+                  <a:srgbClr val="16222E"/>
+                </a:solidFill>
+                <a:latin typeface="Arial"/>
+              </a:rPr>
+              <a:t>•  Plotly · pandas</a:t>
             </a:r>
           </a:p>
         </p:txBody>
@@ -5164,8 +5164,8 @@
         </p:nvSpPr>
         <p:spPr>
           <a:xfrm>
-            <a:off x="6227064" y="3822191"/>
-            <a:ext cx="2697480" cy="2057400"/>
+            <a:off x="6227064" y="3931920"/>
+            <a:ext cx="2697480" cy="2103120"/>
           </a:xfrm>
           <a:prstGeom prst="roundRect">
             <a:avLst/>
@@ -5175,7 +5175,7 @@
           </a:solidFill>
           <a:ln w="15240">
             <a:solidFill>
-              <a:srgbClr val="DBE4EE"/>
+              <a:srgbClr val="CFDAE6"/>
             </a:solidFill>
           </a:ln>
           <a:effectLst/>
@@ -5210,14 +5210,14 @@
         </p:nvSpPr>
         <p:spPr>
           <a:xfrm>
-            <a:off x="6227064" y="3822191"/>
-            <a:ext cx="2697480" cy="420624"/>
+            <a:off x="6227064" y="3931920"/>
+            <a:ext cx="2697480" cy="457200"/>
           </a:xfrm>
           <a:prstGeom prst="roundRect">
             <a:avLst/>
           </a:prstGeom>
           <a:solidFill>
-            <a:srgbClr val="64748B"/>
+            <a:srgbClr val="5B6B7B"/>
           </a:solidFill>
           <a:ln>
             <a:noFill/>
@@ -5254,8 +5254,8 @@
         </p:nvSpPr>
         <p:spPr>
           <a:xfrm>
-            <a:off x="6336792" y="3840479"/>
-            <a:ext cx="2514600" cy="384048"/>
+            <a:off x="6355080" y="3950207"/>
+            <a:ext cx="2478024" cy="420624"/>
           </a:xfrm>
           <a:prstGeom prst="rect">
             <a:avLst/>
@@ -5274,11 +5274,11 @@
               </a:spcAft>
             </a:pPr>
             <a:r>
-              <a:rPr sz="1250" b="1">
+              <a:rPr sz="1400" b="1">
                 <a:solidFill>
                   <a:srgbClr val="FFFFFF"/>
                 </a:solidFill>
-                <a:latin typeface="Helvetica Neue"/>
+                <a:latin typeface="Arial"/>
               </a:rPr>
               <a:t>Data ingestion</a:t>
             </a:r>
@@ -5293,8 +5293,8 @@
         </p:nvSpPr>
         <p:spPr>
           <a:xfrm>
-            <a:off x="6391656" y="4352544"/>
-            <a:ext cx="2423160" cy="1508760"/>
+            <a:off x="6409944" y="4498848"/>
+            <a:ext cx="2386584" cy="1499615"/>
           </a:xfrm>
           <a:prstGeom prst="rect">
             <a:avLst/>
@@ -5309,33 +5309,33 @@
           <a:p>
             <a:pPr algn="l">
               <a:spcAft>
-                <a:spcPts val="300"/>
-              </a:spcAft>
-            </a:pPr>
-            <a:r>
-              <a:rPr sz="1150" b="0">
-                <a:solidFill>
-                  <a:srgbClr val="1B2733"/>
-                </a:solidFill>
-                <a:latin typeface="Helvetica Neue"/>
-              </a:rPr>
-              <a:t>• Binance · Dukascopy</a:t>
+                <a:spcPts val="400"/>
+              </a:spcAft>
+            </a:pPr>
+            <a:r>
+              <a:rPr sz="1350" b="0">
+                <a:solidFill>
+                  <a:srgbClr val="16222E"/>
+                </a:solidFill>
+                <a:latin typeface="Arial"/>
+              </a:rPr>
+              <a:t>•  Binance · Dukascopy</a:t>
             </a:r>
           </a:p>
           <a:p>
             <a:pPr algn="l">
               <a:spcAft>
-                <a:spcPts val="300"/>
-              </a:spcAft>
-            </a:pPr>
-            <a:r>
-              <a:rPr sz="1150" b="0">
-                <a:solidFill>
-                  <a:srgbClr val="1B2733"/>
-                </a:solidFill>
-                <a:latin typeface="Helvetica Neue"/>
-              </a:rPr>
-              <a:t>• economic calendar</a:t>
+                <a:spcPts val="400"/>
+              </a:spcAft>
+            </a:pPr>
+            <a:r>
+              <a:rPr sz="1350" b="0">
+                <a:solidFill>
+                  <a:srgbClr val="16222E"/>
+                </a:solidFill>
+                <a:latin typeface="Arial"/>
+              </a:rPr>
+              <a:t>•  economic calendar</a:t>
             </a:r>
           </a:p>
         </p:txBody>
@@ -5348,8 +5348,8 @@
         </p:nvSpPr>
         <p:spPr>
           <a:xfrm>
-            <a:off x="9089136" y="3822191"/>
-            <a:ext cx="2697480" cy="2057400"/>
+            <a:off x="9089136" y="3931920"/>
+            <a:ext cx="2697480" cy="2103120"/>
           </a:xfrm>
           <a:prstGeom prst="roundRect">
             <a:avLst/>
@@ -5359,7 +5359,7 @@
           </a:solidFill>
           <a:ln w="15240">
             <a:solidFill>
-              <a:srgbClr val="DBE4EE"/>
+              <a:srgbClr val="CFDAE6"/>
             </a:solidFill>
           </a:ln>
           <a:effectLst/>
@@ -5394,14 +5394,14 @@
         </p:nvSpPr>
         <p:spPr>
           <a:xfrm>
-            <a:off x="9089136" y="3822191"/>
-            <a:ext cx="2697480" cy="420624"/>
+            <a:off x="9089136" y="3931920"/>
+            <a:ext cx="2697480" cy="457200"/>
           </a:xfrm>
           <a:prstGeom prst="roundRect">
             <a:avLst/>
           </a:prstGeom>
           <a:solidFill>
-            <a:srgbClr val="E0962F"/>
+            <a:srgbClr val="D98B22"/>
           </a:solidFill>
           <a:ln>
             <a:noFill/>
@@ -5438,8 +5438,8 @@
         </p:nvSpPr>
         <p:spPr>
           <a:xfrm>
-            <a:off x="9198864" y="3840479"/>
-            <a:ext cx="2514600" cy="384048"/>
+            <a:off x="9217152" y="3950207"/>
+            <a:ext cx="2478024" cy="420624"/>
           </a:xfrm>
           <a:prstGeom prst="rect">
             <a:avLst/>
@@ -5458,11 +5458,11 @@
               </a:spcAft>
             </a:pPr>
             <a:r>
-              <a:rPr sz="1250" b="1">
+              <a:rPr sz="1400" b="1">
                 <a:solidFill>
                   <a:srgbClr val="FFFFFF"/>
                 </a:solidFill>
-                <a:latin typeface="Helvetica Neue"/>
+                <a:latin typeface="Arial"/>
               </a:rPr>
               <a:t>Testing</a:t>
             </a:r>
@@ -5477,8 +5477,8 @@
         </p:nvSpPr>
         <p:spPr>
           <a:xfrm>
-            <a:off x="9253728" y="4352544"/>
-            <a:ext cx="2423160" cy="1508760"/>
+            <a:off x="9272016" y="4498848"/>
+            <a:ext cx="2386584" cy="1499615"/>
           </a:xfrm>
           <a:prstGeom prst="rect">
             <a:avLst/>
@@ -5493,33 +5493,33 @@
           <a:p>
             <a:pPr algn="l">
               <a:spcAft>
-                <a:spcPts val="300"/>
-              </a:spcAft>
-            </a:pPr>
-            <a:r>
-              <a:rPr sz="1150" b="0">
-                <a:solidFill>
-                  <a:srgbClr val="1B2733"/>
-                </a:solidFill>
-                <a:latin typeface="Helvetica Neue"/>
-              </a:rPr>
-              <a:t>• pytest — full suite green</a:t>
+                <a:spcPts val="400"/>
+              </a:spcAft>
+            </a:pPr>
+            <a:r>
+              <a:rPr sz="1350" b="0">
+                <a:solidFill>
+                  <a:srgbClr val="16222E"/>
+                </a:solidFill>
+                <a:latin typeface="Arial"/>
+              </a:rPr>
+              <a:t>•  pytest — full suite</a:t>
             </a:r>
           </a:p>
           <a:p>
             <a:pPr algn="l">
               <a:spcAft>
-                <a:spcPts val="300"/>
-              </a:spcAft>
-            </a:pPr>
-            <a:r>
-              <a:rPr sz="1150" b="0">
-                <a:solidFill>
-                  <a:srgbClr val="1B2733"/>
-                </a:solidFill>
-                <a:latin typeface="Helvetica Neue"/>
-              </a:rPr>
-              <a:t>• 211 tests</a:t>
+                <a:spcPts val="400"/>
+              </a:spcAft>
+            </a:pPr>
+            <a:r>
+              <a:rPr sz="1350" b="0">
+                <a:solidFill>
+                  <a:srgbClr val="16222E"/>
+                </a:solidFill>
+                <a:latin typeface="Arial"/>
+              </a:rPr>
+              <a:t>•  211 tests green</a:t>
             </a:r>
           </a:p>
         </p:txBody>
@@ -5638,7 +5638,7 @@
         </p:nvSpPr>
         <p:spPr>
           <a:xfrm>
-            <a:off x="502920" y="6419088"/>
+            <a:off x="502920" y="6400800"/>
             <a:ext cx="5486400" cy="365760"/>
           </a:xfrm>
           <a:prstGeom prst="rect">
@@ -5658,11 +5658,11 @@
               </a:spcAft>
             </a:pPr>
             <a:r>
-              <a:rPr sz="900" b="0">
-                <a:solidFill>
-                  <a:srgbClr val="64748B"/>
-                </a:solidFill>
-                <a:latin typeface="Helvetica Neue"/>
+              <a:rPr sz="1100" b="0">
+                <a:solidFill>
+                  <a:srgbClr val="5B6B7B"/>
+                </a:solidFill>
+                <a:latin typeface="Arial"/>
               </a:rPr>
               <a:t>MT5_Trader</a:t>
             </a:r>
@@ -5677,7 +5677,7 @@
         </p:nvSpPr>
         <p:spPr>
           <a:xfrm>
-            <a:off x="9875520" y="6419088"/>
+            <a:off x="9875520" y="6400800"/>
             <a:ext cx="1828800" cy="365760"/>
           </a:xfrm>
           <a:prstGeom prst="rect">
@@ -5697,11 +5697,11 @@
               </a:spcAft>
             </a:pPr>
             <a:r>
-              <a:rPr sz="900" b="0">
-                <a:solidFill>
-                  <a:srgbClr val="64748B"/>
-                </a:solidFill>
-                <a:latin typeface="Helvetica Neue"/>
+              <a:rPr sz="1100" b="0">
+                <a:solidFill>
+                  <a:srgbClr val="5B6B7B"/>
+                </a:solidFill>
+                <a:latin typeface="Arial"/>
               </a:rPr>
               <a:t>3 / 9</a:t>
             </a:r>
@@ -5716,8 +5716,8 @@
         </p:nvSpPr>
         <p:spPr>
           <a:xfrm>
-            <a:off x="502920" y="411480"/>
-            <a:ext cx="11155680" cy="1005840"/>
+            <a:off x="502920" y="384048"/>
+            <a:ext cx="11155680" cy="1051560"/>
           </a:xfrm>
           <a:prstGeom prst="rect">
             <a:avLst/>
@@ -5736,11 +5736,11 @@
               </a:spcAft>
             </a:pPr>
             <a:r>
-              <a:rPr sz="3000" b="1">
+              <a:rPr sz="3300" b="1">
                 <a:solidFill>
                   <a:srgbClr val="0F2A43"/>
                 </a:solidFill>
-                <a:latin typeface="Helvetica Neue"/>
+                <a:latin typeface="Arial"/>
               </a:rPr>
               <a:t>System architecture</a:t>
             </a:r>
@@ -5752,11 +5752,11 @@
               </a:spcAft>
             </a:pPr>
             <a:r>
-              <a:rPr sz="1400" b="0">
+              <a:rPr sz="1650" b="0">
                 <a:solidFill>
                   <a:srgbClr val="2F6DB0"/>
                 </a:solidFill>
-                <a:latin typeface="Helvetica Neue"/>
+                <a:latin typeface="Arial"/>
               </a:rPr>
               <a:t>data → features → strategies → backtest / live → risk → execution</a:t>
             </a:r>
@@ -5779,8 +5779,8 @@
         </p:blipFill>
         <p:spPr>
           <a:xfrm>
-            <a:off x="2209647" y="1554480"/>
-            <a:ext cx="7772400" cy="4572000"/>
+            <a:off x="2210874" y="1600200"/>
+            <a:ext cx="7769946" cy="4572000"/>
           </a:xfrm>
           <a:prstGeom prst="rect">
             <a:avLst/>
@@ -5901,7 +5901,7 @@
         </p:nvSpPr>
         <p:spPr>
           <a:xfrm>
-            <a:off x="502920" y="6419088"/>
+            <a:off x="502920" y="6400800"/>
             <a:ext cx="5486400" cy="365760"/>
           </a:xfrm>
           <a:prstGeom prst="rect">
@@ -5921,11 +5921,11 @@
               </a:spcAft>
             </a:pPr>
             <a:r>
-              <a:rPr sz="900" b="0">
-                <a:solidFill>
-                  <a:srgbClr val="64748B"/>
-                </a:solidFill>
-                <a:latin typeface="Helvetica Neue"/>
+              <a:rPr sz="1100" b="0">
+                <a:solidFill>
+                  <a:srgbClr val="5B6B7B"/>
+                </a:solidFill>
+                <a:latin typeface="Arial"/>
               </a:rPr>
               <a:t>MT5_Trader</a:t>
             </a:r>
@@ -5940,7 +5940,7 @@
         </p:nvSpPr>
         <p:spPr>
           <a:xfrm>
-            <a:off x="9875520" y="6419088"/>
+            <a:off x="9875520" y="6400800"/>
             <a:ext cx="1828800" cy="365760"/>
           </a:xfrm>
           <a:prstGeom prst="rect">
@@ -5960,11 +5960,11 @@
               </a:spcAft>
             </a:pPr>
             <a:r>
-              <a:rPr sz="900" b="0">
-                <a:solidFill>
-                  <a:srgbClr val="64748B"/>
-                </a:solidFill>
-                <a:latin typeface="Helvetica Neue"/>
+              <a:rPr sz="1100" b="0">
+                <a:solidFill>
+                  <a:srgbClr val="5B6B7B"/>
+                </a:solidFill>
+                <a:latin typeface="Arial"/>
               </a:rPr>
               <a:t>4 / 9</a:t>
             </a:r>
@@ -5979,8 +5979,8 @@
         </p:nvSpPr>
         <p:spPr>
           <a:xfrm>
-            <a:off x="502920" y="411480"/>
-            <a:ext cx="11155680" cy="1005840"/>
+            <a:off x="502920" y="384048"/>
+            <a:ext cx="11155680" cy="1051560"/>
           </a:xfrm>
           <a:prstGeom prst="rect">
             <a:avLst/>
@@ -5999,11 +5999,11 @@
               </a:spcAft>
             </a:pPr>
             <a:r>
-              <a:rPr sz="3000" b="1">
+              <a:rPr sz="3300" b="1">
                 <a:solidFill>
                   <a:srgbClr val="0F2A43"/>
                 </a:solidFill>
-                <a:latin typeface="Helvetica Neue"/>
+                <a:latin typeface="Arial"/>
               </a:rPr>
               <a:t>Data pipeline</a:t>
             </a:r>
@@ -6015,11 +6015,11 @@
               </a:spcAft>
             </a:pPr>
             <a:r>
-              <a:rPr sz="1400" b="0">
+              <a:rPr sz="1650" b="0">
                 <a:solidFill>
                   <a:srgbClr val="2F6DB0"/>
                 </a:solidFill>
-                <a:latin typeface="Helvetica Neue"/>
+                <a:latin typeface="Arial"/>
               </a:rPr>
               <a:t>raw market data → canonical bars → features → signal</a:t>
             </a:r>
@@ -6042,8 +6042,8 @@
         </p:blipFill>
         <p:spPr>
           <a:xfrm>
-            <a:off x="472287" y="1554480"/>
-            <a:ext cx="11247120" cy="2876198"/>
+            <a:off x="426567" y="1600200"/>
+            <a:ext cx="11338560" cy="3174796"/>
           </a:xfrm>
           <a:prstGeom prst="rect">
             <a:avLst/>
@@ -6164,7 +6164,7 @@
         </p:nvSpPr>
         <p:spPr>
           <a:xfrm>
-            <a:off x="502920" y="6419088"/>
+            <a:off x="502920" y="6400800"/>
             <a:ext cx="5486400" cy="365760"/>
           </a:xfrm>
           <a:prstGeom prst="rect">
@@ -6184,11 +6184,11 @@
               </a:spcAft>
             </a:pPr>
             <a:r>
-              <a:rPr sz="900" b="0">
-                <a:solidFill>
-                  <a:srgbClr val="64748B"/>
-                </a:solidFill>
-                <a:latin typeface="Helvetica Neue"/>
+              <a:rPr sz="1100" b="0">
+                <a:solidFill>
+                  <a:srgbClr val="5B6B7B"/>
+                </a:solidFill>
+                <a:latin typeface="Arial"/>
               </a:rPr>
               <a:t>MT5_Trader</a:t>
             </a:r>
@@ -6203,7 +6203,7 @@
         </p:nvSpPr>
         <p:spPr>
           <a:xfrm>
-            <a:off x="9875520" y="6419088"/>
+            <a:off x="9875520" y="6400800"/>
             <a:ext cx="1828800" cy="365760"/>
           </a:xfrm>
           <a:prstGeom prst="rect">
@@ -6223,11 +6223,11 @@
               </a:spcAft>
             </a:pPr>
             <a:r>
-              <a:rPr sz="900" b="0">
-                <a:solidFill>
-                  <a:srgbClr val="64748B"/>
-                </a:solidFill>
-                <a:latin typeface="Helvetica Neue"/>
+              <a:rPr sz="1100" b="0">
+                <a:solidFill>
+                  <a:srgbClr val="5B6B7B"/>
+                </a:solidFill>
+                <a:latin typeface="Arial"/>
               </a:rPr>
               <a:t>5 / 9</a:t>
             </a:r>
@@ -6242,8 +6242,8 @@
         </p:nvSpPr>
         <p:spPr>
           <a:xfrm>
-            <a:off x="502920" y="411480"/>
-            <a:ext cx="11155680" cy="1005840"/>
+            <a:off x="502920" y="384048"/>
+            <a:ext cx="11155680" cy="1051560"/>
           </a:xfrm>
           <a:prstGeom prst="rect">
             <a:avLst/>
@@ -6262,11 +6262,11 @@
               </a:spcAft>
             </a:pPr>
             <a:r>
-              <a:rPr sz="3000" b="1">
+              <a:rPr sz="3300" b="1">
                 <a:solidFill>
                   <a:srgbClr val="0F2A43"/>
                 </a:solidFill>
-                <a:latin typeface="Helvetica Neue"/>
+                <a:latin typeface="Arial"/>
               </a:rPr>
               <a:t>From signal to order</a:t>
             </a:r>
@@ -6278,11 +6278,11 @@
               </a:spcAft>
             </a:pPr>
             <a:r>
-              <a:rPr sz="1400" b="0">
+              <a:rPr sz="1650" b="0">
                 <a:solidFill>
                   <a:srgbClr val="2F6DB0"/>
                 </a:solidFill>
-                <a:latin typeface="Helvetica Neue"/>
+                <a:latin typeface="Arial"/>
               </a:rPr>
               <a:t>one strategy abstraction, two execution paths</a:t>
             </a:r>
@@ -6305,8 +6305,8 @@
         </p:blipFill>
         <p:spPr>
           <a:xfrm>
-            <a:off x="1658479" y="1554480"/>
-            <a:ext cx="8874735" cy="4572000"/>
+            <a:off x="1726229" y="1600200"/>
+            <a:ext cx="8739235" cy="4572000"/>
           </a:xfrm>
           <a:prstGeom prst="rect">
             <a:avLst/>
@@ -6427,7 +6427,7 @@
         </p:nvSpPr>
         <p:spPr>
           <a:xfrm>
-            <a:off x="502920" y="6419088"/>
+            <a:off x="502920" y="6400800"/>
             <a:ext cx="5486400" cy="365760"/>
           </a:xfrm>
           <a:prstGeom prst="rect">
@@ -6447,11 +6447,11 @@
               </a:spcAft>
             </a:pPr>
             <a:r>
-              <a:rPr sz="900" b="0">
-                <a:solidFill>
-                  <a:srgbClr val="64748B"/>
-                </a:solidFill>
-                <a:latin typeface="Helvetica Neue"/>
+              <a:rPr sz="1100" b="0">
+                <a:solidFill>
+                  <a:srgbClr val="5B6B7B"/>
+                </a:solidFill>
+                <a:latin typeface="Arial"/>
               </a:rPr>
               <a:t>MT5_Trader</a:t>
             </a:r>
@@ -6466,7 +6466,7 @@
         </p:nvSpPr>
         <p:spPr>
           <a:xfrm>
-            <a:off x="9875520" y="6419088"/>
+            <a:off x="9875520" y="6400800"/>
             <a:ext cx="1828800" cy="365760"/>
           </a:xfrm>
           <a:prstGeom prst="rect">
@@ -6486,11 +6486,11 @@
               </a:spcAft>
             </a:pPr>
             <a:r>
-              <a:rPr sz="900" b="0">
-                <a:solidFill>
-                  <a:srgbClr val="64748B"/>
-                </a:solidFill>
-                <a:latin typeface="Helvetica Neue"/>
+              <a:rPr sz="1100" b="0">
+                <a:solidFill>
+                  <a:srgbClr val="5B6B7B"/>
+                </a:solidFill>
+                <a:latin typeface="Arial"/>
               </a:rPr>
               <a:t>6 / 9</a:t>
             </a:r>
@@ -6505,8 +6505,8 @@
         </p:nvSpPr>
         <p:spPr>
           <a:xfrm>
-            <a:off x="502920" y="411480"/>
-            <a:ext cx="11155680" cy="1005840"/>
+            <a:off x="502920" y="384048"/>
+            <a:ext cx="11155680" cy="1051560"/>
           </a:xfrm>
           <a:prstGeom prst="rect">
             <a:avLst/>
@@ -6525,13 +6525,29 @@
               </a:spcAft>
             </a:pPr>
             <a:r>
-              <a:rPr sz="3000" b="1">
+              <a:rPr sz="3300" b="1">
                 <a:solidFill>
                   <a:srgbClr val="0F2A43"/>
                 </a:solidFill>
-                <a:latin typeface="Helvetica Neue"/>
+                <a:latin typeface="Arial"/>
               </a:rPr>
               <a:t>Strategy abstraction</a:t>
+            </a:r>
+          </a:p>
+          <a:p>
+            <a:pPr algn="l">
+              <a:spcAft>
+                <a:spcPts val="400"/>
+              </a:spcAft>
+            </a:pPr>
+            <a:r>
+              <a:rPr sz="1650" b="0">
+                <a:solidFill>
+                  <a:srgbClr val="2F6DB0"/>
+                </a:solidFill>
+                <a:latin typeface="Arial"/>
+              </a:rPr>
+              <a:t>one tiny contract every strategy implements</a:t>
             </a:r>
           </a:p>
         </p:txBody>
@@ -6544,8 +6560,8 @@
         </p:nvSpPr>
         <p:spPr>
           <a:xfrm>
-            <a:off x="502920" y="1508760"/>
-            <a:ext cx="6583680" cy="640080"/>
+            <a:off x="502920" y="1627632"/>
+            <a:ext cx="8686800" cy="713232"/>
           </a:xfrm>
           <a:prstGeom prst="roundRect">
             <a:avLst/>
@@ -6588,8 +6604,8 @@
         </p:nvSpPr>
         <p:spPr>
           <a:xfrm>
-            <a:off x="731520" y="1508760"/>
-            <a:ext cx="6400800" cy="640080"/>
+            <a:off x="777240" y="1627632"/>
+            <a:ext cx="8412480" cy="713232"/>
           </a:xfrm>
           <a:prstGeom prst="rect">
             <a:avLst/>
@@ -6608,13 +6624,13 @@
               </a:spcAft>
             </a:pPr>
             <a:r>
-              <a:rPr sz="1400" b="1">
-                <a:solidFill>
-                  <a:srgbClr val="CFE0F2"/>
-                </a:solidFill>
-                <a:latin typeface="Helvetica Neue"/>
-              </a:rPr>
-              <a:t>signal(bars)  →  np.ndarray  (target position ∈ [-1, 1] per bar)</a:t>
+              <a:rPr sz="1600" b="1">
+                <a:solidFill>
+                  <a:srgbClr val="DCEAF7"/>
+                </a:solidFill>
+                <a:latin typeface="Arial"/>
+              </a:rPr>
+              <a:t>signal(bars)  →  one target position in [-1, 1] per bar</a:t>
             </a:r>
           </a:p>
         </p:txBody>
@@ -6627,8 +6643,8 @@
         </p:nvSpPr>
         <p:spPr>
           <a:xfrm>
-            <a:off x="502920" y="2523744"/>
-            <a:ext cx="109728" cy="457200"/>
+            <a:off x="502920" y="2715768"/>
+            <a:ext cx="118872" cy="502920"/>
           </a:xfrm>
           <a:prstGeom prst="roundRect">
             <a:avLst/>
@@ -6671,8 +6687,8 @@
         </p:nvSpPr>
         <p:spPr>
           <a:xfrm>
-            <a:off x="822960" y="2468880"/>
-            <a:ext cx="10789920" cy="731520"/>
+            <a:off x="841248" y="2670048"/>
+            <a:ext cx="10881360" cy="749808"/>
           </a:xfrm>
           <a:prstGeom prst="rect">
             <a:avLst/>
@@ -6691,13 +6707,22 @@
               </a:spcAft>
             </a:pPr>
             <a:r>
-              <a:rPr sz="1500" b="0">
-                <a:solidFill>
-                  <a:srgbClr val="1B2733"/>
-                </a:solidFill>
-                <a:latin typeface="Helvetica Neue"/>
-              </a:rPr>
-              <a:t>Every strategy is a “book”: an object exposing signal(bars).</a:t>
+              <a:rPr sz="1650" b="1">
+                <a:solidFill>
+                  <a:srgbClr val="0F2A43"/>
+                </a:solidFill>
+                <a:latin typeface="Arial"/>
+              </a:rPr>
+              <a:t>One method.  </a:t>
+            </a:r>
+            <a:r>
+              <a:rPr sz="1650" b="0">
+                <a:solidFill>
+                  <a:srgbClr val="16222E"/>
+                </a:solidFill>
+                <a:latin typeface="Arial"/>
+              </a:rPr>
+              <a:t>A strategy is a “book” — nothing but signal(bars). −1 = full short, +1 = full long.</a:t>
             </a:r>
           </a:p>
         </p:txBody>
@@ -6710,8 +6735,8 @@
         </p:nvSpPr>
         <p:spPr>
           <a:xfrm>
-            <a:off x="502920" y="3273552"/>
-            <a:ext cx="109728" cy="457200"/>
+            <a:off x="502920" y="3465575"/>
+            <a:ext cx="118872" cy="502920"/>
           </a:xfrm>
           <a:prstGeom prst="roundRect">
             <a:avLst/>
@@ -6754,8 +6779,8 @@
         </p:nvSpPr>
         <p:spPr>
           <a:xfrm>
-            <a:off x="822960" y="3218688"/>
-            <a:ext cx="10789920" cy="731520"/>
+            <a:off x="841248" y="3419856"/>
+            <a:ext cx="10881360" cy="749808"/>
           </a:xfrm>
           <a:prstGeom prst="rect">
             <a:avLst/>
@@ -6774,13 +6799,22 @@
               </a:spcAft>
             </a:pPr>
             <a:r>
-              <a:rPr sz="1500" b="0">
-                <a:solidFill>
-                  <a:srgbClr val="1B2733"/>
-                </a:solidFill>
-                <a:latin typeface="Helvetica Neue"/>
-              </a:rPr>
-              <a:t>Books self-register into a REGISTRY via @register; engine, validator and live runner resolve books by name.</a:t>
+              <a:rPr sz="1650" b="1">
+                <a:solidFill>
+                  <a:srgbClr val="0F2A43"/>
+                </a:solidFill>
+                <a:latin typeface="Arial"/>
+              </a:rPr>
+              <a:t>Auto-discovered.  </a:t>
+            </a:r>
+            <a:r>
+              <a:rPr sz="1650" b="0">
+                <a:solidFill>
+                  <a:srgbClr val="16222E"/>
+                </a:solidFill>
+                <a:latin typeface="Arial"/>
+              </a:rPr>
+              <a:t>@register adds a book; the engine, validator and live runner all find it by name.</a:t>
             </a:r>
           </a:p>
         </p:txBody>
@@ -6793,8 +6827,8 @@
         </p:nvSpPr>
         <p:spPr>
           <a:xfrm>
-            <a:off x="502920" y="4023359"/>
-            <a:ext cx="109728" cy="457200"/>
+            <a:off x="502920" y="4215383"/>
+            <a:ext cx="118872" cy="502920"/>
           </a:xfrm>
           <a:prstGeom prst="roundRect">
             <a:avLst/>
@@ -6837,8 +6871,8 @@
         </p:nvSpPr>
         <p:spPr>
           <a:xfrm>
-            <a:off x="822960" y="3968496"/>
-            <a:ext cx="10789920" cy="731520"/>
+            <a:off x="841248" y="4169663"/>
+            <a:ext cx="10881360" cy="749808"/>
           </a:xfrm>
           <a:prstGeom prst="rect">
             <a:avLst/>
@@ -6857,13 +6891,22 @@
               </a:spcAft>
             </a:pPr>
             <a:r>
-              <a:rPr sz="1500" b="0">
-                <a:solidFill>
-                  <a:srgbClr val="1B2733"/>
-                </a:solidFill>
-                <a:latin typeface="Helvetica Neue"/>
-              </a:rPr>
-              <a:t>No-lookahead by construction: signal[t] uses data ≤ t; the engine shifts execution one bar.</a:t>
+              <a:rPr sz="1650" b="1">
+                <a:solidFill>
+                  <a:srgbClr val="0F2A43"/>
+                </a:solidFill>
+                <a:latin typeface="Arial"/>
+              </a:rPr>
+              <a:t>No look-ahead.  </a:t>
+            </a:r>
+            <a:r>
+              <a:rPr sz="1650" b="0">
+                <a:solidFill>
+                  <a:srgbClr val="16222E"/>
+                </a:solidFill>
+                <a:latin typeface="Arial"/>
+              </a:rPr>
+              <a:t>signal[t] sees only data up to bar t — the engine trades it one bar later.</a:t>
             </a:r>
           </a:p>
         </p:txBody>
@@ -6876,8 +6919,8 @@
         </p:nvSpPr>
         <p:spPr>
           <a:xfrm>
-            <a:off x="502920" y="4773168"/>
-            <a:ext cx="109728" cy="457200"/>
+            <a:off x="502920" y="4965192"/>
+            <a:ext cx="118872" cy="502920"/>
           </a:xfrm>
           <a:prstGeom prst="roundRect">
             <a:avLst/>
@@ -6920,8 +6963,8 @@
         </p:nvSpPr>
         <p:spPr>
           <a:xfrm>
-            <a:off x="822960" y="4718304"/>
-            <a:ext cx="10789920" cy="731520"/>
+            <a:off x="841248" y="4919472"/>
+            <a:ext cx="10881360" cy="749808"/>
           </a:xfrm>
           <a:prstGeom prst="rect">
             <a:avLst/>
@@ -6940,13 +6983,22 @@
               </a:spcAft>
             </a:pPr>
             <a:r>
-              <a:rPr sz="1500" b="0">
-                <a:solidFill>
-                  <a:srgbClr val="1B2733"/>
-                </a:solidFill>
-                <a:latin typeface="Helvetica Neue"/>
-              </a:rPr>
-              <a:t>Add a strategy = copy strategy_template.py, implement signal(), register. No engine changes.</a:t>
+              <a:rPr sz="1650" b="1">
+                <a:solidFill>
+                  <a:srgbClr val="0F2A43"/>
+                </a:solidFill>
+                <a:latin typeface="Arial"/>
+              </a:rPr>
+              <a:t>Add in one file.  </a:t>
+            </a:r>
+            <a:r>
+              <a:rPr sz="1650" b="0">
+                <a:solidFill>
+                  <a:srgbClr val="16222E"/>
+                </a:solidFill>
+                <a:latin typeface="Arial"/>
+              </a:rPr>
+              <a:t>Copy the template, write signal(). No engine changes, no plumbing.</a:t>
             </a:r>
           </a:p>
         </p:txBody>
@@ -6959,8 +7011,8 @@
         </p:nvSpPr>
         <p:spPr>
           <a:xfrm>
-            <a:off x="502920" y="5522976"/>
-            <a:ext cx="109728" cy="457200"/>
+            <a:off x="502920" y="5715000"/>
+            <a:ext cx="118872" cy="502920"/>
           </a:xfrm>
           <a:prstGeom prst="roundRect">
             <a:avLst/>
@@ -7003,8 +7055,8 @@
         </p:nvSpPr>
         <p:spPr>
           <a:xfrm>
-            <a:off x="822960" y="5468112"/>
-            <a:ext cx="10789920" cy="731520"/>
+            <a:off x="841248" y="5669280"/>
+            <a:ext cx="10881360" cy="749808"/>
           </a:xfrm>
           <a:prstGeom prst="rect">
             <a:avLst/>
@@ -7023,13 +7075,22 @@
               </a:spcAft>
             </a:pPr>
             <a:r>
-              <a:rPr sz="1500" b="0">
-                <a:solidFill>
-                  <a:srgbClr val="1B2733"/>
-                </a:solidFill>
-                <a:latin typeface="Helvetica Neue"/>
-              </a:rPr>
-              <a:t>Portfolio = weighted books in config/portfolio.yaml; targets netted per symbol before ordering.</a:t>
+              <a:rPr sz="1650" b="1">
+                <a:solidFill>
+                  <a:srgbClr val="0F2A43"/>
+                </a:solidFill>
+                <a:latin typeface="Arial"/>
+              </a:rPr>
+              <a:t>Compose a portfolio.  </a:t>
+            </a:r>
+            <a:r>
+              <a:rPr sz="1650" b="0">
+                <a:solidFill>
+                  <a:srgbClr val="16222E"/>
+                </a:solidFill>
+                <a:latin typeface="Arial"/>
+              </a:rPr>
+              <a:t>Weight the books in config; targets are netted per symbol before ordering.</a:t>
             </a:r>
           </a:p>
         </p:txBody>
@@ -7148,7 +7209,7 @@
         </p:nvSpPr>
         <p:spPr>
           <a:xfrm>
-            <a:off x="502920" y="6419088"/>
+            <a:off x="502920" y="6400800"/>
             <a:ext cx="5486400" cy="365760"/>
           </a:xfrm>
           <a:prstGeom prst="rect">
@@ -7168,11 +7229,11 @@
               </a:spcAft>
             </a:pPr>
             <a:r>
-              <a:rPr sz="900" b="0">
-                <a:solidFill>
-                  <a:srgbClr val="64748B"/>
-                </a:solidFill>
-                <a:latin typeface="Helvetica Neue"/>
+              <a:rPr sz="1100" b="0">
+                <a:solidFill>
+                  <a:srgbClr val="5B6B7B"/>
+                </a:solidFill>
+                <a:latin typeface="Arial"/>
               </a:rPr>
               <a:t>MT5_Trader</a:t>
             </a:r>
@@ -7187,7 +7248,7 @@
         </p:nvSpPr>
         <p:spPr>
           <a:xfrm>
-            <a:off x="9875520" y="6419088"/>
+            <a:off x="9875520" y="6400800"/>
             <a:ext cx="1828800" cy="365760"/>
           </a:xfrm>
           <a:prstGeom prst="rect">
@@ -7207,11 +7268,11 @@
               </a:spcAft>
             </a:pPr>
             <a:r>
-              <a:rPr sz="900" b="0">
-                <a:solidFill>
-                  <a:srgbClr val="64748B"/>
-                </a:solidFill>
-                <a:latin typeface="Helvetica Neue"/>
+              <a:rPr sz="1100" b="0">
+                <a:solidFill>
+                  <a:srgbClr val="5B6B7B"/>
+                </a:solidFill>
+                <a:latin typeface="Arial"/>
               </a:rPr>
               <a:t>7 / 9</a:t>
             </a:r>
@@ -7226,8 +7287,8 @@
         </p:nvSpPr>
         <p:spPr>
           <a:xfrm>
-            <a:off x="502920" y="411480"/>
-            <a:ext cx="11155680" cy="1005840"/>
+            <a:off x="502920" y="384048"/>
+            <a:ext cx="11155680" cy="1051560"/>
           </a:xfrm>
           <a:prstGeom prst="rect">
             <a:avLst/>
@@ -7246,11 +7307,11 @@
               </a:spcAft>
             </a:pPr>
             <a:r>
-              <a:rPr sz="3000" b="1">
+              <a:rPr sz="3300" b="1">
                 <a:solidFill>
                   <a:srgbClr val="0F2A43"/>
                 </a:solidFill>
-                <a:latin typeface="Helvetica Neue"/>
+                <a:latin typeface="Arial"/>
               </a:rPr>
               <a:t>AI-native by design</a:t>
             </a:r>
@@ -7262,11 +7323,11 @@
               </a:spcAft>
             </a:pPr>
             <a:r>
-              <a:rPr sz="1400" b="0">
+              <a:rPr sz="1650" b="0">
                 <a:solidFill>
                   <a:srgbClr val="2F6DB0"/>
                 </a:solidFill>
-                <a:latin typeface="Helvetica Neue"/>
+                <a:latin typeface="Arial"/>
               </a:rPr>
               <a:t>built with — and built for — AI coding agents</a:t>
             </a:r>
@@ -7282,7 +7343,7 @@
         <p:spPr>
           <a:xfrm>
             <a:off x="502920" y="1481328"/>
-            <a:ext cx="11155680" cy="841248"/>
+            <a:ext cx="11155680" cy="859536"/>
           </a:xfrm>
           <a:prstGeom prst="roundRect">
             <a:avLst/>
@@ -7292,7 +7353,7 @@
           </a:solidFill>
           <a:ln w="15240">
             <a:solidFill>
-              <a:srgbClr val="DBE4EE"/>
+              <a:srgbClr val="CFDAE6"/>
             </a:solidFill>
           </a:ln>
           <a:effectLst/>
@@ -7328,7 +7389,7 @@
         <p:spPr>
           <a:xfrm>
             <a:off x="502920" y="1481328"/>
-            <a:ext cx="128016" cy="841248"/>
+            <a:ext cx="137160" cy="859536"/>
           </a:xfrm>
           <a:prstGeom prst="roundRect">
             <a:avLst/>
@@ -7371,8 +7432,8 @@
         </p:nvSpPr>
         <p:spPr>
           <a:xfrm>
-            <a:off x="777240" y="1700784"/>
-            <a:ext cx="402336" cy="402336"/>
+            <a:off x="786384" y="1709928"/>
+            <a:ext cx="420624" cy="420624"/>
           </a:xfrm>
           <a:prstGeom prst="ellipse">
             <a:avLst/>
@@ -7415,8 +7476,8 @@
         </p:nvSpPr>
         <p:spPr>
           <a:xfrm>
-            <a:off x="777240" y="1700784"/>
-            <a:ext cx="402336" cy="402336"/>
+            <a:off x="786384" y="1709928"/>
+            <a:ext cx="420624" cy="420624"/>
           </a:xfrm>
           <a:prstGeom prst="rect">
             <a:avLst/>
@@ -7435,11 +7496,11 @@
               </a:spcAft>
             </a:pPr>
             <a:r>
-              <a:rPr sz="1600" b="1">
+              <a:rPr sz="1800" b="1">
                 <a:solidFill>
                   <a:srgbClr val="FFFFFF"/>
                 </a:solidFill>
-                <a:latin typeface="Helvetica Neue"/>
+                <a:latin typeface="Arial"/>
               </a:rPr>
               <a:t>1</a:t>
             </a:r>
@@ -7454,8 +7515,8 @@
         </p:nvSpPr>
         <p:spPr>
           <a:xfrm>
-            <a:off x="1417320" y="1591056"/>
-            <a:ext cx="10058400" cy="658368"/>
+            <a:off x="1444752" y="1572768"/>
+            <a:ext cx="10058400" cy="694944"/>
           </a:xfrm>
           <a:prstGeom prst="rect">
             <a:avLst/>
@@ -7474,20 +7535,20 @@
               </a:spcAft>
             </a:pPr>
             <a:r>
-              <a:rPr sz="1500" b="1">
+              <a:rPr sz="1600" b="1">
                 <a:solidFill>
                   <a:srgbClr val="0F2A43"/>
                 </a:solidFill>
-                <a:latin typeface="Helvetica Neue"/>
+                <a:latin typeface="Arial"/>
               </a:rPr>
               <a:t>Built with AI agents  —  </a:t>
             </a:r>
             <a:r>
-              <a:rPr sz="1300" b="0">
-                <a:solidFill>
-                  <a:srgbClr val="1B2733"/>
-                </a:solidFill>
-                <a:latin typeface="Helvetica Neue"/>
+              <a:rPr sz="1400" b="0">
+                <a:solidFill>
+                  <a:srgbClr val="16222E"/>
+                </a:solidFill>
+                <a:latin typeface="Arial"/>
               </a:rPr>
               <a:t>Developed end-to-end with AI coding agents; repo conventions (CLAUDE.md, typed contracts, tests) steer the agent.</a:t>
             </a:r>
@@ -7502,8 +7563,8 @@
         </p:nvSpPr>
         <p:spPr>
           <a:xfrm>
-            <a:off x="502920" y="2450592"/>
-            <a:ext cx="11155680" cy="841248"/>
+            <a:off x="502920" y="2468880"/>
+            <a:ext cx="11155680" cy="859536"/>
           </a:xfrm>
           <a:prstGeom prst="roundRect">
             <a:avLst/>
@@ -7513,7 +7574,7 @@
           </a:solidFill>
           <a:ln w="15240">
             <a:solidFill>
-              <a:srgbClr val="DBE4EE"/>
+              <a:srgbClr val="CFDAE6"/>
             </a:solidFill>
           </a:ln>
           <a:effectLst/>
@@ -7548,8 +7609,8 @@
         </p:nvSpPr>
         <p:spPr>
           <a:xfrm>
-            <a:off x="502920" y="2450592"/>
-            <a:ext cx="128016" cy="841248"/>
+            <a:off x="502920" y="2468880"/>
+            <a:ext cx="137160" cy="859536"/>
           </a:xfrm>
           <a:prstGeom prst="roundRect">
             <a:avLst/>
@@ -7592,8 +7653,8 @@
         </p:nvSpPr>
         <p:spPr>
           <a:xfrm>
-            <a:off x="777240" y="2670048"/>
-            <a:ext cx="402336" cy="402336"/>
+            <a:off x="786384" y="2697480"/>
+            <a:ext cx="420624" cy="420624"/>
           </a:xfrm>
           <a:prstGeom prst="ellipse">
             <a:avLst/>
@@ -7636,8 +7697,8 @@
         </p:nvSpPr>
         <p:spPr>
           <a:xfrm>
-            <a:off x="777240" y="2670048"/>
-            <a:ext cx="402336" cy="402336"/>
+            <a:off x="786384" y="2697480"/>
+            <a:ext cx="420624" cy="420624"/>
           </a:xfrm>
           <a:prstGeom prst="rect">
             <a:avLst/>
@@ -7656,11 +7717,11 @@
               </a:spcAft>
             </a:pPr>
             <a:r>
-              <a:rPr sz="1600" b="1">
+              <a:rPr sz="1800" b="1">
                 <a:solidFill>
                   <a:srgbClr val="FFFFFF"/>
                 </a:solidFill>
-                <a:latin typeface="Helvetica Neue"/>
+                <a:latin typeface="Arial"/>
               </a:rPr>
               <a:t>2</a:t>
             </a:r>
@@ -7675,8 +7736,8 @@
         </p:nvSpPr>
         <p:spPr>
           <a:xfrm>
-            <a:off x="1417320" y="2560320"/>
-            <a:ext cx="10058400" cy="658368"/>
+            <a:off x="1444752" y="2560320"/>
+            <a:ext cx="10058400" cy="694944"/>
           </a:xfrm>
           <a:prstGeom prst="rect">
             <a:avLst/>
@@ -7695,22 +7756,22 @@
               </a:spcAft>
             </a:pPr>
             <a:r>
-              <a:rPr sz="1500" b="1">
+              <a:rPr sz="1600" b="1">
                 <a:solidFill>
                   <a:srgbClr val="0F2A43"/>
                 </a:solidFill>
-                <a:latin typeface="Helvetica Neue"/>
+                <a:latin typeface="Arial"/>
               </a:rPr>
               <a:t>Agent-friendly extension  —  </a:t>
             </a:r>
             <a:r>
-              <a:rPr sz="1300" b="0">
-                <a:solidFill>
-                  <a:srgbClr val="1B2733"/>
-                </a:solidFill>
-                <a:latin typeface="Helvetica Neue"/>
-              </a:rPr>
-              <a:t>One narrow contract — signal(bars) → position. Registry auto-discovery; copy strategy_template.py to add an edge, no engine changes.</a:t>
+              <a:rPr sz="1400" b="0">
+                <a:solidFill>
+                  <a:srgbClr val="16222E"/>
+                </a:solidFill>
+                <a:latin typeface="Arial"/>
+              </a:rPr>
+              <a:t>One narrow contract — signal(bars) → position. Registry auto-discovery; copy a template to add an edge, no engine changes.</a:t>
             </a:r>
           </a:p>
         </p:txBody>
@@ -7723,8 +7784,8 @@
         </p:nvSpPr>
         <p:spPr>
           <a:xfrm>
-            <a:off x="502920" y="3419856"/>
-            <a:ext cx="11155680" cy="841248"/>
+            <a:off x="502920" y="3456432"/>
+            <a:ext cx="11155680" cy="859536"/>
           </a:xfrm>
           <a:prstGeom prst="roundRect">
             <a:avLst/>
@@ -7734,7 +7795,7 @@
           </a:solidFill>
           <a:ln w="15240">
             <a:solidFill>
-              <a:srgbClr val="DBE4EE"/>
+              <a:srgbClr val="CFDAE6"/>
             </a:solidFill>
           </a:ln>
           <a:effectLst/>
@@ -7769,14 +7830,14 @@
         </p:nvSpPr>
         <p:spPr>
           <a:xfrm>
-            <a:off x="502920" y="3419856"/>
-            <a:ext cx="128016" cy="841248"/>
+            <a:off x="502920" y="3456432"/>
+            <a:ext cx="137160" cy="859536"/>
           </a:xfrm>
           <a:prstGeom prst="roundRect">
             <a:avLst/>
           </a:prstGeom>
           <a:solidFill>
-            <a:srgbClr val="E0962F"/>
+            <a:srgbClr val="D98B22"/>
           </a:solidFill>
           <a:ln>
             <a:noFill/>
@@ -7813,14 +7874,14 @@
         </p:nvSpPr>
         <p:spPr>
           <a:xfrm>
-            <a:off x="777240" y="3639312"/>
-            <a:ext cx="402336" cy="402336"/>
+            <a:off x="786384" y="3685032"/>
+            <a:ext cx="420624" cy="420624"/>
           </a:xfrm>
           <a:prstGeom prst="ellipse">
             <a:avLst/>
           </a:prstGeom>
           <a:solidFill>
-            <a:srgbClr val="E0962F"/>
+            <a:srgbClr val="D98B22"/>
           </a:solidFill>
           <a:ln>
             <a:noFill/>
@@ -7857,8 +7918,8 @@
         </p:nvSpPr>
         <p:spPr>
           <a:xfrm>
-            <a:off x="777240" y="3639312"/>
-            <a:ext cx="402336" cy="402336"/>
+            <a:off x="786384" y="3685032"/>
+            <a:ext cx="420624" cy="420624"/>
           </a:xfrm>
           <a:prstGeom prst="rect">
             <a:avLst/>
@@ -7877,11 +7938,11 @@
               </a:spcAft>
             </a:pPr>
             <a:r>
-              <a:rPr sz="1600" b="1">
+              <a:rPr sz="1800" b="1">
                 <a:solidFill>
                   <a:srgbClr val="FFFFFF"/>
                 </a:solidFill>
-                <a:latin typeface="Helvetica Neue"/>
+                <a:latin typeface="Arial"/>
               </a:rPr>
               <a:t>3</a:t>
             </a:r>
@@ -7896,8 +7957,8 @@
         </p:nvSpPr>
         <p:spPr>
           <a:xfrm>
-            <a:off x="1417320" y="3529584"/>
-            <a:ext cx="10058400" cy="658368"/>
+            <a:off x="1444752" y="3547872"/>
+            <a:ext cx="10058400" cy="694944"/>
           </a:xfrm>
           <a:prstGeom prst="rect">
             <a:avLst/>
@@ -7916,20 +7977,20 @@
               </a:spcAft>
             </a:pPr>
             <a:r>
-              <a:rPr sz="1500" b="1">
+              <a:rPr sz="1600" b="1">
                 <a:solidFill>
                   <a:srgbClr val="0F2A43"/>
                 </a:solidFill>
-                <a:latin typeface="Helvetica Neue"/>
+                <a:latin typeface="Arial"/>
               </a:rPr>
               <a:t>Machine-readable research loop  —  </a:t>
             </a:r>
             <a:r>
-              <a:rPr sz="1300" b="0">
-                <a:solidFill>
-                  <a:srgbClr val="1B2733"/>
-                </a:solidFill>
-                <a:latin typeface="Helvetica Neue"/>
+              <a:rPr sz="1400" b="0">
+                <a:solidFill>
+                  <a:srgbClr val="16222E"/>
+                </a:solidFill>
+                <a:latin typeface="Arial"/>
               </a:rPr>
               <a:t>Structured trials / stash / verdicts + automated validation gates emit a PASS/FAIL verdict an agent can act on.</a:t>
             </a:r>
@@ -7944,8 +8005,8 @@
         </p:nvSpPr>
         <p:spPr>
           <a:xfrm>
-            <a:off x="502920" y="4389120"/>
-            <a:ext cx="11155680" cy="841248"/>
+            <a:off x="502920" y="4443984"/>
+            <a:ext cx="11155680" cy="859536"/>
           </a:xfrm>
           <a:prstGeom prst="roundRect">
             <a:avLst/>
@@ -7955,7 +8016,7 @@
           </a:solidFill>
           <a:ln w="15240">
             <a:solidFill>
-              <a:srgbClr val="DBE4EE"/>
+              <a:srgbClr val="CFDAE6"/>
             </a:solidFill>
           </a:ln>
           <a:effectLst/>
@@ -7990,8 +8051,8 @@
         </p:nvSpPr>
         <p:spPr>
           <a:xfrm>
-            <a:off x="502920" y="4389120"/>
-            <a:ext cx="128016" cy="841248"/>
+            <a:off x="502920" y="4443984"/>
+            <a:ext cx="137160" cy="859536"/>
           </a:xfrm>
           <a:prstGeom prst="roundRect">
             <a:avLst/>
@@ -8034,8 +8095,8 @@
         </p:nvSpPr>
         <p:spPr>
           <a:xfrm>
-            <a:off x="777240" y="4608576"/>
-            <a:ext cx="402336" cy="402336"/>
+            <a:off x="786384" y="4672584"/>
+            <a:ext cx="420624" cy="420624"/>
           </a:xfrm>
           <a:prstGeom prst="ellipse">
             <a:avLst/>
@@ -8078,8 +8139,8 @@
         </p:nvSpPr>
         <p:spPr>
           <a:xfrm>
-            <a:off x="777240" y="4608576"/>
-            <a:ext cx="402336" cy="402336"/>
+            <a:off x="786384" y="4672584"/>
+            <a:ext cx="420624" cy="420624"/>
           </a:xfrm>
           <a:prstGeom prst="rect">
             <a:avLst/>
@@ -8098,11 +8159,11 @@
               </a:spcAft>
             </a:pPr>
             <a:r>
-              <a:rPr sz="1600" b="1">
+              <a:rPr sz="1800" b="1">
                 <a:solidFill>
                   <a:srgbClr val="FFFFFF"/>
                 </a:solidFill>
-                <a:latin typeface="Helvetica Neue"/>
+                <a:latin typeface="Arial"/>
               </a:rPr>
               <a:t>4</a:t>
             </a:r>
@@ -8117,8 +8178,8 @@
         </p:nvSpPr>
         <p:spPr>
           <a:xfrm>
-            <a:off x="1417320" y="4498848"/>
-            <a:ext cx="10058400" cy="658368"/>
+            <a:off x="1444752" y="4535424"/>
+            <a:ext cx="10058400" cy="694944"/>
           </a:xfrm>
           <a:prstGeom prst="rect">
             <a:avLst/>
@@ -8137,22 +8198,22 @@
               </a:spcAft>
             </a:pPr>
             <a:r>
-              <a:rPr sz="1500" b="1">
+              <a:rPr sz="1600" b="1">
                 <a:solidFill>
                   <a:srgbClr val="0F2A43"/>
                 </a:solidFill>
-                <a:latin typeface="Helvetica Neue"/>
+                <a:latin typeface="Arial"/>
               </a:rPr>
               <a:t>Guardrails for autonomous iteration  —  </a:t>
             </a:r>
             <a:r>
-              <a:rPr sz="1300" b="0">
-                <a:solidFill>
-                  <a:srgbClr val="1B2733"/>
-                </a:solidFill>
-                <a:latin typeface="Helvetica Neue"/>
-              </a:rPr>
-              <a:t>No-lookahead enforced by tests for every strategy; evidence gate before sizing; 211-test suite is the agent's feedback signal.</a:t>
+              <a:rPr sz="1400" b="0">
+                <a:solidFill>
+                  <a:srgbClr val="16222E"/>
+                </a:solidFill>
+                <a:latin typeface="Arial"/>
+              </a:rPr>
+              <a:t>No-lookahead enforced by tests for every strategy; evidence gate before sizing; 211-test suite is the feedback signal.</a:t>
             </a:r>
           </a:p>
         </p:txBody>
@@ -8165,8 +8226,8 @@
         </p:nvSpPr>
         <p:spPr>
           <a:xfrm>
-            <a:off x="502920" y="5394960"/>
-            <a:ext cx="11155680" cy="566928"/>
+            <a:off x="502920" y="5449824"/>
+            <a:ext cx="11155680" cy="585216"/>
           </a:xfrm>
           <a:prstGeom prst="roundRect">
             <a:avLst/>
@@ -8209,8 +8270,8 @@
         </p:nvSpPr>
         <p:spPr>
           <a:xfrm>
-            <a:off x="731520" y="5394960"/>
-            <a:ext cx="10789920" cy="566928"/>
+            <a:off x="749808" y="5449824"/>
+            <a:ext cx="10881360" cy="585216"/>
           </a:xfrm>
           <a:prstGeom prst="rect">
             <a:avLst/>
@@ -8229,20 +8290,20 @@
               </a:spcAft>
             </a:pPr>
             <a:r>
-              <a:rPr sz="1300" b="1">
+              <a:rPr sz="1400" b="1">
                 <a:solidFill>
                   <a:srgbClr val="2A9D8F"/>
                 </a:solidFill>
-                <a:latin typeface="Helvetica Neue"/>
-              </a:rPr>
-              <a:t>research loop:   </a:t>
-            </a:r>
-            <a:r>
-              <a:rPr sz="1350" b="0">
-                <a:solidFill>
-                  <a:srgbClr val="CFE0F2"/>
-                </a:solidFill>
-                <a:latin typeface="Helvetica Neue"/>
+                <a:latin typeface="Arial"/>
+              </a:rPr>
+              <a:t>research loop:    </a:t>
+            </a:r>
+            <a:r>
+              <a:rPr sz="1400" b="0">
+                <a:solidFill>
+                  <a:srgbClr val="DCEAF7"/>
+                </a:solidFill>
+                <a:latin typeface="Arial"/>
               </a:rPr>
               <a:t>propose  →  backtest  →  validation gates  →  verdict  →  promote / stash</a:t>
             </a:r>
@@ -8363,7 +8424,7 @@
         </p:nvSpPr>
         <p:spPr>
           <a:xfrm>
-            <a:off x="502920" y="6419088"/>
+            <a:off x="502920" y="6400800"/>
             <a:ext cx="5486400" cy="365760"/>
           </a:xfrm>
           <a:prstGeom prst="rect">
@@ -8383,11 +8444,11 @@
               </a:spcAft>
             </a:pPr>
             <a:r>
-              <a:rPr sz="900" b="0">
-                <a:solidFill>
-                  <a:srgbClr val="64748B"/>
-                </a:solidFill>
-                <a:latin typeface="Helvetica Neue"/>
+              <a:rPr sz="1100" b="0">
+                <a:solidFill>
+                  <a:srgbClr val="5B6B7B"/>
+                </a:solidFill>
+                <a:latin typeface="Arial"/>
               </a:rPr>
               <a:t>MT5_Trader</a:t>
             </a:r>
@@ -8402,7 +8463,7 @@
         </p:nvSpPr>
         <p:spPr>
           <a:xfrm>
-            <a:off x="9875520" y="6419088"/>
+            <a:off x="9875520" y="6400800"/>
             <a:ext cx="1828800" cy="365760"/>
           </a:xfrm>
           <a:prstGeom prst="rect">
@@ -8422,11 +8483,11 @@
               </a:spcAft>
             </a:pPr>
             <a:r>
-              <a:rPr sz="900" b="0">
-                <a:solidFill>
-                  <a:srgbClr val="64748B"/>
-                </a:solidFill>
-                <a:latin typeface="Helvetica Neue"/>
+              <a:rPr sz="1100" b="0">
+                <a:solidFill>
+                  <a:srgbClr val="5B6B7B"/>
+                </a:solidFill>
+                <a:latin typeface="Arial"/>
               </a:rPr>
               <a:t>8 / 9</a:t>
             </a:r>
@@ -8441,8 +8502,8 @@
         </p:nvSpPr>
         <p:spPr>
           <a:xfrm>
-            <a:off x="502920" y="411480"/>
-            <a:ext cx="11155680" cy="1005840"/>
+            <a:off x="502920" y="384048"/>
+            <a:ext cx="11155680" cy="1051560"/>
           </a:xfrm>
           <a:prstGeom prst="rect">
             <a:avLst/>
@@ -8461,11 +8522,11 @@
               </a:spcAft>
             </a:pPr>
             <a:r>
-              <a:rPr sz="3000" b="1">
+              <a:rPr sz="3300" b="1">
                 <a:solidFill>
                   <a:srgbClr val="0F2A43"/>
                 </a:solidFill>
-                <a:latin typeface="Helvetica Neue"/>
+                <a:latin typeface="Arial"/>
               </a:rPr>
               <a:t>Repository layout</a:t>
             </a:r>
@@ -8480,8 +8541,8 @@
         </p:nvSpPr>
         <p:spPr>
           <a:xfrm>
-            <a:off x="502920" y="1508760"/>
-            <a:ext cx="11155680" cy="4572000"/>
+            <a:off x="502920" y="1554480"/>
+            <a:ext cx="11155680" cy="4526280"/>
           </a:xfrm>
           <a:prstGeom prst="roundRect">
             <a:avLst/>
@@ -8524,8 +8585,8 @@
         </p:nvSpPr>
         <p:spPr>
           <a:xfrm>
-            <a:off x="822960" y="1737360"/>
-            <a:ext cx="10607040" cy="4206240"/>
+            <a:off x="868680" y="1783080"/>
+            <a:ext cx="10607040" cy="4114800"/>
           </a:xfrm>
           <a:prstGeom prst="rect">
             <a:avLst/>
@@ -8540,11 +8601,11 @@
           <a:p>
             <a:pPr>
               <a:spcAft>
-                <a:spcPts val="300"/>
-              </a:spcAft>
-            </a:pPr>
-            <a:r>
-              <a:rPr sz="1450" b="1">
+                <a:spcPts val="400"/>
+              </a:spcAft>
+            </a:pPr>
+            <a:r>
+              <a:rPr sz="1550" b="1">
                 <a:solidFill>
                   <a:srgbClr val="9BD0C6"/>
                 </a:solidFill>
@@ -8556,13 +8617,13 @@
           <a:p>
             <a:pPr>
               <a:spcAft>
-                <a:spcPts val="300"/>
-              </a:spcAft>
-            </a:pPr>
-            <a:r>
-              <a:rPr sz="1450" b="0">
-                <a:solidFill>
-                  <a:srgbClr val="B9C6D4"/>
+                <a:spcPts val="400"/>
+              </a:spcAft>
+            </a:pPr>
+            <a:r>
+              <a:rPr sz="1550" b="0">
+                <a:solidFill>
+                  <a:srgbClr val="C3D0DD"/>
                 </a:solidFill>
                 <a:latin typeface="Menlo"/>
               </a:rPr>
@@ -8572,13 +8633,13 @@
           <a:p>
             <a:pPr>
               <a:spcAft>
-                <a:spcPts val="300"/>
-              </a:spcAft>
-            </a:pPr>
-            <a:r>
-              <a:rPr sz="1450" b="0">
-                <a:solidFill>
-                  <a:srgbClr val="B9C6D4"/>
+                <a:spcPts val="400"/>
+              </a:spcAft>
+            </a:pPr>
+            <a:r>
+              <a:rPr sz="1550" b="0">
+                <a:solidFill>
+                  <a:srgbClr val="C3D0DD"/>
                 </a:solidFill>
                 <a:latin typeface="Menlo"/>
               </a:rPr>
@@ -8588,13 +8649,13 @@
           <a:p>
             <a:pPr>
               <a:spcAft>
-                <a:spcPts val="300"/>
-              </a:spcAft>
-            </a:pPr>
-            <a:r>
-              <a:rPr sz="1450" b="0">
-                <a:solidFill>
-                  <a:srgbClr val="B9C6D4"/>
+                <a:spcPts val="400"/>
+              </a:spcAft>
+            </a:pPr>
+            <a:r>
+              <a:rPr sz="1550" b="0">
+                <a:solidFill>
+                  <a:srgbClr val="C3D0DD"/>
                 </a:solidFill>
                 <a:latin typeface="Menlo"/>
               </a:rPr>
@@ -8604,13 +8665,13 @@
           <a:p>
             <a:pPr>
               <a:spcAft>
-                <a:spcPts val="300"/>
-              </a:spcAft>
-            </a:pPr>
-            <a:r>
-              <a:rPr sz="1450" b="0">
-                <a:solidFill>
-                  <a:srgbClr val="B9C6D4"/>
+                <a:spcPts val="400"/>
+              </a:spcAft>
+            </a:pPr>
+            <a:r>
+              <a:rPr sz="1550" b="0">
+                <a:solidFill>
+                  <a:srgbClr val="C3D0DD"/>
                 </a:solidFill>
                 <a:latin typeface="Menlo"/>
               </a:rPr>
@@ -8620,13 +8681,13 @@
           <a:p>
             <a:pPr>
               <a:spcAft>
-                <a:spcPts val="300"/>
-              </a:spcAft>
-            </a:pPr>
-            <a:r>
-              <a:rPr sz="1450" b="0">
-                <a:solidFill>
-                  <a:srgbClr val="B9C6D4"/>
+                <a:spcPts val="400"/>
+              </a:spcAft>
+            </a:pPr>
+            <a:r>
+              <a:rPr sz="1550" b="0">
+                <a:solidFill>
+                  <a:srgbClr val="C3D0DD"/>
                 </a:solidFill>
                 <a:latin typeface="Menlo"/>
               </a:rPr>
@@ -8636,13 +8697,13 @@
           <a:p>
             <a:pPr>
               <a:spcAft>
-                <a:spcPts val="300"/>
-              </a:spcAft>
-            </a:pPr>
-            <a:r>
-              <a:rPr sz="1450" b="0">
-                <a:solidFill>
-                  <a:srgbClr val="B9C6D4"/>
+                <a:spcPts val="400"/>
+              </a:spcAft>
+            </a:pPr>
+            <a:r>
+              <a:rPr sz="1550" b="0">
+                <a:solidFill>
+                  <a:srgbClr val="C3D0DD"/>
                 </a:solidFill>
                 <a:latin typeface="Menlo"/>
               </a:rPr>
@@ -8652,13 +8713,13 @@
           <a:p>
             <a:pPr>
               <a:spcAft>
-                <a:spcPts val="300"/>
-              </a:spcAft>
-            </a:pPr>
-            <a:r>
-              <a:rPr sz="1450" b="0">
-                <a:solidFill>
-                  <a:srgbClr val="B9C6D4"/>
+                <a:spcPts val="400"/>
+              </a:spcAft>
+            </a:pPr>
+            <a:r>
+              <a:rPr sz="1550" b="0">
+                <a:solidFill>
+                  <a:srgbClr val="C3D0DD"/>
                 </a:solidFill>
                 <a:latin typeface="Menlo"/>
               </a:rPr>
@@ -8668,11 +8729,11 @@
           <a:p>
             <a:pPr>
               <a:spcAft>
-                <a:spcPts val="300"/>
-              </a:spcAft>
-            </a:pPr>
-            <a:r>
-              <a:rPr sz="1450" b="1">
+                <a:spcPts val="400"/>
+              </a:spcAft>
+            </a:pPr>
+            <a:r>
+              <a:rPr sz="1550" b="1">
                 <a:solidFill>
                   <a:srgbClr val="9BD0C6"/>
                 </a:solidFill>
@@ -8684,11 +8745,11 @@
           <a:p>
             <a:pPr>
               <a:spcAft>
-                <a:spcPts val="300"/>
-              </a:spcAft>
-            </a:pPr>
-            <a:r>
-              <a:rPr sz="1450" b="1">
+                <a:spcPts val="400"/>
+              </a:spcAft>
+            </a:pPr>
+            <a:r>
+              <a:rPr sz="1550" b="1">
                 <a:solidFill>
                   <a:srgbClr val="9BD0C6"/>
                 </a:solidFill>
@@ -8700,11 +8761,11 @@
           <a:p>
             <a:pPr>
               <a:spcAft>
-                <a:spcPts val="300"/>
-              </a:spcAft>
-            </a:pPr>
-            <a:r>
-              <a:rPr sz="1450" b="1">
+                <a:spcPts val="400"/>
+              </a:spcAft>
+            </a:pPr>
+            <a:r>
+              <a:rPr sz="1550" b="1">
                 <a:solidFill>
                   <a:srgbClr val="9BD0C6"/>
                 </a:solidFill>
@@ -8716,11 +8777,11 @@
           <a:p>
             <a:pPr>
               <a:spcAft>
-                <a:spcPts val="300"/>
-              </a:spcAft>
-            </a:pPr>
-            <a:r>
-              <a:rPr sz="1450" b="1">
+                <a:spcPts val="400"/>
+              </a:spcAft>
+            </a:pPr>
+            <a:r>
+              <a:rPr sz="1550" b="1">
                 <a:solidFill>
                   <a:srgbClr val="9BD0C6"/>
                 </a:solidFill>
@@ -8845,7 +8906,7 @@
         </p:nvSpPr>
         <p:spPr>
           <a:xfrm>
-            <a:off x="502920" y="6419088"/>
+            <a:off x="502920" y="6400800"/>
             <a:ext cx="5486400" cy="365760"/>
           </a:xfrm>
           <a:prstGeom prst="rect">
@@ -8865,11 +8926,11 @@
               </a:spcAft>
             </a:pPr>
             <a:r>
-              <a:rPr sz="900" b="0">
-                <a:solidFill>
-                  <a:srgbClr val="64748B"/>
-                </a:solidFill>
-                <a:latin typeface="Helvetica Neue"/>
+              <a:rPr sz="1100" b="0">
+                <a:solidFill>
+                  <a:srgbClr val="5B6B7B"/>
+                </a:solidFill>
+                <a:latin typeface="Arial"/>
               </a:rPr>
               <a:t>MT5_Trader</a:t>
             </a:r>
@@ -8884,7 +8945,7 @@
         </p:nvSpPr>
         <p:spPr>
           <a:xfrm>
-            <a:off x="9875520" y="6419088"/>
+            <a:off x="9875520" y="6400800"/>
             <a:ext cx="1828800" cy="365760"/>
           </a:xfrm>
           <a:prstGeom prst="rect">
@@ -8904,11 +8965,11 @@
               </a:spcAft>
             </a:pPr>
             <a:r>
-              <a:rPr sz="900" b="0">
-                <a:solidFill>
-                  <a:srgbClr val="64748B"/>
-                </a:solidFill>
-                <a:latin typeface="Helvetica Neue"/>
+              <a:rPr sz="1100" b="0">
+                <a:solidFill>
+                  <a:srgbClr val="5B6B7B"/>
+                </a:solidFill>
+                <a:latin typeface="Arial"/>
               </a:rPr>
               <a:t>9 / 9</a:t>
             </a:r>
@@ -8923,8 +8984,8 @@
         </p:nvSpPr>
         <p:spPr>
           <a:xfrm>
-            <a:off x="502920" y="411480"/>
-            <a:ext cx="11155680" cy="1005840"/>
+            <a:off x="502920" y="384048"/>
+            <a:ext cx="11155680" cy="1051560"/>
           </a:xfrm>
           <a:prstGeom prst="rect">
             <a:avLst/>
@@ -8943,13 +9004,29 @@
               </a:spcAft>
             </a:pPr>
             <a:r>
-              <a:rPr sz="3000" b="1">
+              <a:rPr sz="3300" b="1">
                 <a:solidFill>
                   <a:srgbClr val="0F2A43"/>
                 </a:solidFill>
-                <a:latin typeface="Helvetica Neue"/>
+                <a:latin typeface="Arial"/>
               </a:rPr>
               <a:t>How it runs &amp; how it's tested</a:t>
+            </a:r>
+          </a:p>
+          <a:p>
+            <a:pPr algn="l">
+              <a:spcAft>
+                <a:spcPts val="400"/>
+              </a:spcAft>
+            </a:pPr>
+            <a:r>
+              <a:rPr sz="1650" b="0">
+                <a:solidFill>
+                  <a:srgbClr val="2F6DB0"/>
+                </a:solidFill>
+                <a:latin typeface="Arial"/>
+              </a:rPr>
+              <a:t>research locally · deploy live on a VPS</a:t>
             </a:r>
           </a:p>
         </p:txBody>
@@ -8962,8 +9039,8 @@
         </p:nvSpPr>
         <p:spPr>
           <a:xfrm>
-            <a:off x="502920" y="1554480"/>
-            <a:ext cx="3657600" cy="457200"/>
+            <a:off x="502920" y="1627632"/>
+            <a:ext cx="2286000" cy="530352"/>
           </a:xfrm>
           <a:prstGeom prst="rect">
             <a:avLst/>
@@ -8982,13 +9059,13 @@
               </a:spcAft>
             </a:pPr>
             <a:r>
-              <a:rPr sz="1400" b="1">
+              <a:rPr sz="1500" b="1">
                 <a:solidFill>
                   <a:srgbClr val="2F6DB0"/>
                 </a:solidFill>
-                <a:latin typeface="Helvetica Neue"/>
-              </a:rPr>
-              <a:t>Research (macOS)</a:t>
+                <a:latin typeface="Arial"/>
+              </a:rPr>
+              <a:t>Research</a:t>
             </a:r>
           </a:p>
         </p:txBody>
@@ -9001,8 +9078,8 @@
         </p:nvSpPr>
         <p:spPr>
           <a:xfrm>
-            <a:off x="4023360" y="1554480"/>
-            <a:ext cx="7589520" cy="502920"/>
+            <a:off x="2788920" y="1627632"/>
+            <a:ext cx="8869680" cy="530352"/>
           </a:xfrm>
           <a:prstGeom prst="roundRect">
             <a:avLst/>
@@ -9045,8 +9122,8 @@
         </p:nvSpPr>
         <p:spPr>
           <a:xfrm>
-            <a:off x="4206240" y="1554480"/>
-            <a:ext cx="7315200" cy="502920"/>
+            <a:off x="3017520" y="1627632"/>
+            <a:ext cx="8503920" cy="530352"/>
           </a:xfrm>
           <a:prstGeom prst="rect">
             <a:avLst/>
@@ -9065,11 +9142,11 @@
               </a:spcAft>
             </a:pPr>
             <a:r>
-              <a:rPr sz="1250" b="0">
-                <a:solidFill>
-                  <a:srgbClr val="CFE0F2"/>
-                </a:solidFill>
-                <a:latin typeface="Helvetica Neue"/>
+              <a:rPr sz="1350" b="0">
+                <a:solidFill>
+                  <a:srgbClr val="DCEAF7"/>
+                </a:solidFill>
+                <a:latin typeface="Arial"/>
               </a:rPr>
               <a:t>uv sync --extra dev   ·   uv run pytest</a:t>
             </a:r>
@@ -9084,8 +9161,8 @@
         </p:nvSpPr>
         <p:spPr>
           <a:xfrm>
-            <a:off x="502920" y="2267712"/>
-            <a:ext cx="3657600" cy="457200"/>
+            <a:off x="502920" y="2377440"/>
+            <a:ext cx="2286000" cy="530352"/>
           </a:xfrm>
           <a:prstGeom prst="rect">
             <a:avLst/>
@@ -9104,11 +9181,11 @@
               </a:spcAft>
             </a:pPr>
             <a:r>
-              <a:rPr sz="1400" b="1">
+              <a:rPr sz="1500" b="1">
                 <a:solidFill>
                   <a:srgbClr val="2F6DB0"/>
                 </a:solidFill>
-                <a:latin typeface="Helvetica Neue"/>
+                <a:latin typeface="Arial"/>
               </a:rPr>
               <a:t>Backtest</a:t>
             </a:r>
@@ -9123,8 +9200,8 @@
         </p:nvSpPr>
         <p:spPr>
           <a:xfrm>
-            <a:off x="4023360" y="2267712"/>
-            <a:ext cx="7589520" cy="502920"/>
+            <a:off x="2788920" y="2377440"/>
+            <a:ext cx="8869680" cy="530352"/>
           </a:xfrm>
           <a:prstGeom prst="roundRect">
             <a:avLst/>
@@ -9167,8 +9244,8 @@
         </p:nvSpPr>
         <p:spPr>
           <a:xfrm>
-            <a:off x="4206240" y="2267712"/>
-            <a:ext cx="7315200" cy="502920"/>
+            <a:off x="3017520" y="2377440"/>
+            <a:ext cx="8503920" cy="530352"/>
           </a:xfrm>
           <a:prstGeom prst="rect">
             <a:avLst/>
@@ -9187,11 +9264,11 @@
               </a:spcAft>
             </a:pPr>
             <a:r>
-              <a:rPr sz="1250" b="0">
-                <a:solidFill>
-                  <a:srgbClr val="CFE0F2"/>
-                </a:solidFill>
-                <a:latin typeface="Helvetica Neue"/>
+              <a:rPr sz="1350" b="0">
+                <a:solidFill>
+                  <a:srgbClr val="DCEAF7"/>
+                </a:solidFill>
+                <a:latin typeface="Arial"/>
               </a:rPr>
               <a:t>uv run scripts/run_backtest.py --strategy vwap_trend --symbol XAUUSD</a:t>
             </a:r>
@@ -9206,8 +9283,8 @@
         </p:nvSpPr>
         <p:spPr>
           <a:xfrm>
-            <a:off x="502920" y="2980944"/>
-            <a:ext cx="3657600" cy="457200"/>
+            <a:off x="502920" y="3127248"/>
+            <a:ext cx="2286000" cy="530352"/>
           </a:xfrm>
           <a:prstGeom prst="rect">
             <a:avLst/>
@@ -9226,13 +9303,13 @@
               </a:spcAft>
             </a:pPr>
             <a:r>
-              <a:rPr sz="1400" b="1">
+              <a:rPr sz="1500" b="1">
                 <a:solidFill>
                   <a:srgbClr val="2F6DB0"/>
                 </a:solidFill>
-                <a:latin typeface="Helvetica Neue"/>
-              </a:rPr>
-              <a:t>Live (Windows VPS)</a:t>
+                <a:latin typeface="Arial"/>
+              </a:rPr>
+              <a:t>Go live</a:t>
             </a:r>
           </a:p>
         </p:txBody>
@@ -9245,8 +9322,8 @@
         </p:nvSpPr>
         <p:spPr>
           <a:xfrm>
-            <a:off x="4023360" y="2980944"/>
-            <a:ext cx="7589520" cy="502920"/>
+            <a:off x="2788920" y="3127248"/>
+            <a:ext cx="8869680" cy="530352"/>
           </a:xfrm>
           <a:prstGeom prst="roundRect">
             <a:avLst/>
@@ -9289,8 +9366,8 @@
         </p:nvSpPr>
         <p:spPr>
           <a:xfrm>
-            <a:off x="4206240" y="2980944"/>
-            <a:ext cx="7315200" cy="502920"/>
+            <a:off x="3017520" y="3127248"/>
+            <a:ext cx="8503920" cy="530352"/>
           </a:xfrm>
           <a:prstGeom prst="rect">
             <a:avLst/>
@@ -9309,13 +9386,13 @@
               </a:spcAft>
             </a:pPr>
             <a:r>
-              <a:rPr sz="1250" b="0">
-                <a:solidFill>
-                  <a:srgbClr val="CFE0F2"/>
-                </a:solidFill>
-                <a:latin typeface="Helvetica Neue"/>
-              </a:rPr>
-              <a:t>python scripts/run_portfolio.py   (MT5 terminal + creds via env)</a:t>
+              <a:rPr sz="1350" b="0">
+                <a:solidFill>
+                  <a:srgbClr val="DCEAF7"/>
+                </a:solidFill>
+                <a:latin typeface="Arial"/>
+              </a:rPr>
+              <a:t>python scripts/run_portfolio.py   (MT5 + creds via env, on Windows)</a:t>
             </a:r>
           </a:p>
         </p:txBody>
@@ -9328,14 +9405,14 @@
         </p:nvSpPr>
         <p:spPr>
           <a:xfrm>
-            <a:off x="502920" y="3886200"/>
-            <a:ext cx="109728" cy="457200"/>
+            <a:off x="502920" y="4123944"/>
+            <a:ext cx="118872" cy="502920"/>
           </a:xfrm>
           <a:prstGeom prst="roundRect">
             <a:avLst/>
           </a:prstGeom>
           <a:solidFill>
-            <a:srgbClr val="E0962F"/>
+            <a:srgbClr val="D98B22"/>
           </a:solidFill>
           <a:ln>
             <a:noFill/>
@@ -9372,8 +9449,8 @@
         </p:nvSpPr>
         <p:spPr>
           <a:xfrm>
-            <a:off x="822960" y="3831336"/>
-            <a:ext cx="10789920" cy="731520"/>
+            <a:off x="841248" y="4078224"/>
+            <a:ext cx="10881360" cy="749808"/>
           </a:xfrm>
           <a:prstGeom prst="rect">
             <a:avLst/>
@@ -9392,13 +9469,22 @@
               </a:spcAft>
             </a:pPr>
             <a:r>
-              <a:rPr sz="1400" b="0">
-                <a:solidFill>
-                  <a:srgbClr val="1B2733"/>
-                </a:solidFill>
-                <a:latin typeface="Helvetica Neue"/>
-              </a:rPr>
-              <a:t>Validation gates score every candidate: week-by-week, cost-stress, param-wiggle, walk-forward, deflated-Sharpe.</a:t>
+              <a:rPr sz="1550" b="1">
+                <a:solidFill>
+                  <a:srgbClr val="0F2A43"/>
+                </a:solidFill>
+                <a:latin typeface="Arial"/>
+              </a:rPr>
+              <a:t>Every edge is gated.  </a:t>
+            </a:r>
+            <a:r>
+              <a:rPr sz="1500" b="0">
+                <a:solidFill>
+                  <a:srgbClr val="16222E"/>
+                </a:solidFill>
+                <a:latin typeface="Arial"/>
+              </a:rPr>
+              <a:t>Five checks before it trades — consistent weekly, survives 4× costs, parameter-robust, out-of-sample, multiple-testing adjusted.</a:t>
             </a:r>
           </a:p>
         </p:txBody>
@@ -9411,14 +9497,14 @@
         </p:nvSpPr>
         <p:spPr>
           <a:xfrm>
-            <a:off x="502920" y="4617720"/>
-            <a:ext cx="109728" cy="457200"/>
+            <a:off x="502920" y="4873752"/>
+            <a:ext cx="118872" cy="502920"/>
           </a:xfrm>
           <a:prstGeom prst="roundRect">
             <a:avLst/>
           </a:prstGeom>
           <a:solidFill>
-            <a:srgbClr val="E0962F"/>
+            <a:srgbClr val="D98B22"/>
           </a:solidFill>
           <a:ln>
             <a:noFill/>
@@ -9455,8 +9541,8 @@
         </p:nvSpPr>
         <p:spPr>
           <a:xfrm>
-            <a:off x="822960" y="4562856"/>
-            <a:ext cx="10789920" cy="731520"/>
+            <a:off x="841248" y="4828032"/>
+            <a:ext cx="10881360" cy="749808"/>
           </a:xfrm>
           <a:prstGeom prst="rect">
             <a:avLst/>
@@ -9475,13 +9561,22 @@
               </a:spcAft>
             </a:pPr>
             <a:r>
-              <a:rPr sz="1400" b="0">
-                <a:solidFill>
-                  <a:srgbClr val="1B2733"/>
-                </a:solidFill>
-                <a:latin typeface="Helvetica Neue"/>
-              </a:rPr>
-              <a:t>Risk overlays run on the net position: vol targeting, daily kill switch, optional vol-guard / event blackout.</a:t>
+              <a:rPr sz="1550" b="1">
+                <a:solidFill>
+                  <a:srgbClr val="0F2A43"/>
+                </a:solidFill>
+                <a:latin typeface="Arial"/>
+              </a:rPr>
+              <a:t>Risk sits on top.  </a:t>
+            </a:r>
+            <a:r>
+              <a:rPr sz="1500" b="0">
+                <a:solidFill>
+                  <a:srgbClr val="16222E"/>
+                </a:solidFill>
+                <a:latin typeface="Arial"/>
+              </a:rPr>
+              <a:t>Vol-targeted sizing and a daily kill switch on the net position; optional spike and event mutes.</a:t>
             </a:r>
           </a:p>
         </p:txBody>
@@ -9494,14 +9589,14 @@
         </p:nvSpPr>
         <p:spPr>
           <a:xfrm>
-            <a:off x="502920" y="5349240"/>
-            <a:ext cx="109728" cy="457200"/>
+            <a:off x="502920" y="5623560"/>
+            <a:ext cx="118872" cy="502920"/>
           </a:xfrm>
           <a:prstGeom prst="roundRect">
             <a:avLst/>
           </a:prstGeom>
           <a:solidFill>
-            <a:srgbClr val="E0962F"/>
+            <a:srgbClr val="D98B22"/>
           </a:solidFill>
           <a:ln>
             <a:noFill/>
@@ -9538,8 +9633,8 @@
         </p:nvSpPr>
         <p:spPr>
           <a:xfrm>
-            <a:off x="822960" y="5294376"/>
-            <a:ext cx="10789920" cy="731520"/>
+            <a:off x="841248" y="5577840"/>
+            <a:ext cx="10881360" cy="749808"/>
           </a:xfrm>
           <a:prstGeom prst="rect">
             <a:avLst/>
@@ -9558,13 +9653,22 @@
               </a:spcAft>
             </a:pPr>
             <a:r>
-              <a:rPr sz="1400" b="0">
-                <a:solidFill>
-                  <a:srgbClr val="1B2733"/>
-                </a:solidFill>
-                <a:latin typeface="Helvetica Neue"/>
-              </a:rPr>
-              <a:t>Monitoring: runner logs → Streamlit dashboard + Telegram daily report.</a:t>
+              <a:rPr sz="1550" b="1">
+                <a:solidFill>
+                  <a:srgbClr val="0F2A43"/>
+                </a:solidFill>
+                <a:latin typeface="Arial"/>
+              </a:rPr>
+              <a:t>Always watched.  </a:t>
+            </a:r>
+            <a:r>
+              <a:rPr sz="1500" b="0">
+                <a:solidFill>
+                  <a:srgbClr val="16222E"/>
+                </a:solidFill>
+                <a:latin typeface="Arial"/>
+              </a:rPr>
+              <a:t>Runner logs feed a Streamlit dashboard and a Telegram daily report.</a:t>
             </a:r>
           </a:p>
         </p:txBody>

</xml_diff>